<commit_message>
feat: update presentation slides with intuitive 7 security games and student details, clean redundant docs
</commit_message>
<xml_diff>
--- a/docs/Bao_Cao_Giua_Ky_DT05.pptx
+++ b/docs/Bao_Cao_Giua_Ky_DT05.pptx
@@ -22,6 +22,7 @@
     <p:sldId id="270" r:id="rId21"/>
     <p:sldId id="271" r:id="rId22"/>
     <p:sldId id="272" r:id="rId23"/>
+    <p:sldId id="273" r:id="rId24"/>
   </p:sldIdLst>
   <p:sldSz cx="12191695" cy="6858000" type="screen4x3"/>
   <p:notesSz cx="6858000" cy="9144000"/>
@@ -3269,34 +3270,7 @@
               </a:defRPr>
             </a:pPr>
             <a:r>
-              <a:t>TRƯỜNG ĐẠI HỌC KHOA HỌC TỰ NHIÊN - ĐẠI HỌC QUỐC GIA TP. HỒ CHÍ MINH</a:t>
-            </a:r>
-          </a:p>
-          <a:p>
-            <a:pPr algn="ctr">
-              <a:spcAft>
-                <a:spcPts val="1800"/>
-              </a:spcAft>
-              <a:defRPr sz="1150">
-                <a:solidFill>
-                  <a:srgbClr val="64748B"/>
-                </a:solidFill>
-              </a:defRPr>
-            </a:pPr>
-            <a:r>
-              <a:t>KHOA CÔNG NGHỆ THÔNG TIN - BỘ MÔN AN TOÀN VÀ BẢO MẬT HỆ THỐNG THÔNG TIN</a:t>
-            </a:r>
-          </a:p>
-          <a:p>
-            <a:pPr algn="ctr">
-              <a:defRPr b="1" sz="2200">
-                <a:solidFill>
-                  <a:srgbClr val="DC2626"/>
-                </a:solidFill>
-              </a:defRPr>
-            </a:pPr>
-            <a:r>
-              <a:t>BÁO CÁO THUYẾT TRÌNH ĐỒ ÁN GIỮA KỲ</a:t>
+              <a:t>TRƯỜNG ĐẠI HỌC TÀI NGUYÊN VÀ MÔI TRƯỜNG TP. HỒ CHÍ MINH</a:t>
             </a:r>
           </a:p>
           <a:p>
@@ -3304,7 +3278,34 @@
               <a:spcAft>
                 <a:spcPts val="1400"/>
               </a:spcAft>
-              <a:defRPr b="1" sz="1650">
+              <a:defRPr b="1" sz="1200">
+                <a:solidFill>
+                  <a:srgbClr val="2563EB"/>
+                </a:solidFill>
+              </a:defRPr>
+            </a:pPr>
+            <a:r>
+              <a:t>KHOA CÔNG NGHỆ THÔNG TIN</a:t>
+            </a:r>
+          </a:p>
+          <a:p>
+            <a:pPr algn="ctr">
+              <a:defRPr b="1" sz="2200">
+                <a:solidFill>
+                  <a:srgbClr val="DC2626"/>
+                </a:solidFill>
+              </a:defRPr>
+            </a:pPr>
+            <a:r>
+              <a:t>BÁO CÁO THUYẾT TRÌNH ĐỒ ÁN GIỮA KỲ</a:t>
+            </a:r>
+          </a:p>
+          <a:p>
+            <a:pPr algn="ctr">
+              <a:spcAft>
+                <a:spcPts val="1000"/>
+              </a:spcAft>
+              <a:defRPr b="1" sz="1550">
                 <a:solidFill>
                   <a:srgbClr val="1E3A8A"/>
                 </a:solidFill>
@@ -3318,43 +3319,62 @@
             <a:pPr algn="ctr">
               <a:defRPr b="1" sz="1200">
                 <a:solidFill>
-                  <a:srgbClr val="2563EB"/>
-                </a:solidFill>
-              </a:defRPr>
-            </a:pPr>
-            <a:r>
-              <a:t>Nghiên Cứu Và Tái Lập Dựa Trên Bài Báo Khoa Học Quốc Tế Gốc Tiếng Anh:</a:t>
+                  <a:srgbClr val="0F172A"/>
+                </a:solidFill>
+              </a:defRPr>
+            </a:pPr>
+            <a:r>
+              <a:t>Học phần: An Toàn và Bảo Mật Hệ Thống Thông Tin</a:t>
             </a:r>
           </a:p>
           <a:p>
             <a:pPr algn="ctr">
               <a:spcAft>
-                <a:spcPts val="1600"/>
+                <a:spcPts val="1200"/>
               </a:spcAft>
-              <a:defRPr sz="1150">
-                <a:solidFill>
-                  <a:srgbClr val="0F172A"/>
-                </a:solidFill>
-              </a:defRPr>
-            </a:pPr>
-            <a:r>
-              <a:t>The Adversary: The Philosophy of Cryptography - Tác giả Harry Halpin</a:t>
+              <a:defRPr b="1" sz="1250">
+                <a:solidFill>
+                  <a:srgbClr val="1E3A8A"/>
+                </a:solidFill>
+              </a:defRPr>
+            </a:pPr>
+            <a:r>
+              <a:t>Giảng viên hướng dẫn: ThS. Phạm Trọng Huynh</a:t>
             </a:r>
             <a:br/>
             <a:r>
-              <a:t>Xuất bản trên Tạp chí An ninh mạng Oxford (Oxford Journal of Cybersecurity), Tập 11, Số 1, Năm 2025</a:t>
+              <a:t>Sinh viên thực hiện: Võ Anh Kiệt  —  MSSV: 1150080143  —  Lớp: 11_CNPM2</a:t>
             </a:r>
           </a:p>
           <a:p>
             <a:pPr algn="ctr">
-              <a:defRPr b="1" sz="1100">
+              <a:spcAft>
+                <a:spcPts val="800"/>
+              </a:spcAft>
+              <a:defRPr sz="1000">
+                <a:solidFill>
+                  <a:srgbClr val="64748B"/>
+                </a:solidFill>
+              </a:defRPr>
+            </a:pPr>
+            <a:r>
+              <a:t>Nghiên Cứu Và Phát Triển Dựa Trên Bài Báo Khoa Học Gốc: The Adversary: The Philosophy of Cryptography</a:t>
+            </a:r>
+            <a:br/>
+            <a:r>
+              <a:t>Tác giả: Harry Halpin — Xuất bản trên Tạp chí An ninh mạng Oxford (Oxford Journal of Cybersecurity, 2025)</a:t>
+            </a:r>
+          </a:p>
+          <a:p>
+            <a:pPr algn="ctr">
+              <a:defRPr b="1" sz="1050">
                 <a:solidFill>
                   <a:srgbClr val="059669"/>
                 </a:solidFill>
               </a:defRPr>
             </a:pPr>
             <a:r>
-              <a:t>Phương Pháp Luận Nghiên Cứu: Triển khai 3 Trụ cột độc lập (Kỹ thuật hệ thống PoC, Mô phỏng an ninh hình thức 7 Games, Thực nghiệm trên 1.000 tệp)</a:t>
+              <a:t>Phương Pháp Luận Nghiên Cứu: Triển khai 3 Trụ cột độc lập (Kỹ thuật PoC, Mô phỏng an ninh 7 Games, Thực nghiệm trên 1.000 tệp)</a:t>
             </a:r>
           </a:p>
         </p:txBody>
@@ -6410,7 +6430,7 @@
               </a:defRPr>
             </a:pPr>
             <a:r>
-              <a:t>13. Khung Kiểm Định 7 Mô Hình An Toàn Mật Mã Học Theo Harry Halpin</a:t>
+              <a:t>13. Khung 7 Trò Chơi An Ninh Mật Mã Học (Games 1 – 4: Va Chạm, Mạng, Nút &amp; Tuyết Lở)</a:t>
             </a:r>
           </a:p>
         </p:txBody>
@@ -6424,7 +6444,7 @@
         <p:spPr>
           <a:xfrm>
             <a:off x="731520" y="1234440"/>
-            <a:ext cx="5120640" cy="5257800"/>
+            <a:ext cx="5303520" cy="5257800"/>
           </a:xfrm>
           <a:prstGeom prst="roundRect">
             <a:avLst/>
@@ -6469,7 +6489,7 @@
         <p:spPr>
           <a:xfrm>
             <a:off x="960120" y="1399032"/>
-            <a:ext cx="4663440" cy="4965192"/>
+            <a:ext cx="4846320" cy="4965192"/>
           </a:xfrm>
           <a:prstGeom prst="rect">
             <a:avLst/>
@@ -6490,7 +6510,7 @@
               </a:defRPr>
             </a:pPr>
             <a:r>
-              <a:t>Khung Kiểm Định Đầy Đủ 7 Trò Chơi An Ninh (security_games.py)</a:t>
+              <a:t>Bốn Mô Hình Kiểm Định Toán Học Đối Kháng (Games 1 – 4)</a:t>
             </a:r>
           </a:p>
           <a:p>
@@ -6498,14 +6518,14 @@
               <a:spcBef>
                 <a:spcPts val="500"/>
               </a:spcBef>
-              <a:defRPr b="1" sz="840">
+              <a:defRPr b="1" sz="820">
                 <a:solidFill>
                   <a:srgbClr val="2563EB"/>
                 </a:solidFill>
               </a:defRPr>
             </a:pPr>
             <a:r>
-              <a:t>• Khởi chạy độc lập: python src/proposed_model/security_games.py</a:t>
+              <a:t>• Game 1: Chống tấn công tìm va chạm mã băm (PPT Adversary):</a:t>
             </a:r>
           </a:p>
           <a:p>
@@ -6513,14 +6533,26 @@
               <a:spcBef>
                 <a:spcPts val="150"/>
               </a:spcBef>
-              <a:defRPr sz="760">
+              <a:defRPr sz="740">
                 <a:solidFill>
                   <a:srgbClr val="0F172A"/>
                 </a:solidFill>
               </a:defRPr>
             </a:pPr>
             <a:r>
-              <a:t>Module an ninh độc lập không gộp chung benchmark; trực tiếp kiểm thử toán học 7 giả định đối đầu của Harry Halpin:</a:t>
+              <a:t>1. Ý nghĩa: Kẻ tấn công có năng lực tính toán ngẫu nhiên nhưng bị giới hạn về thời gian và tài nguyên (đa thức).</a:t>
+            </a:r>
+            <a:br/>
+            <a:r>
+              <a:t>2. Cách tấn công: Cố tìm 2 tệp khác nhau A != B sao cho SHA256(A) = SHA256(B) để đánh lừa hệ thống.</a:t>
+            </a:r>
+            <a:br/>
+            <a:r>
+              <a:t>3. Cách phòng thủ: SHA-256 (256-bit). Tìm va chạm ngẫu nhiên đòi hỏi ~2^128 phép băm theo Birthday bound.</a:t>
+            </a:r>
+            <a:br/>
+            <a:r>
+              <a:t>4. Kết quả: Thử nghiệm 50 lượt ngẫu nhiên: Kẻ thù thắng 0/50 (0.0%), lợi thế đối thủ Adv &lt;= 2^-128.</a:t>
             </a:r>
           </a:p>
           <a:p>
@@ -6528,14 +6560,14 @@
               <a:spcBef>
                 <a:spcPts val="500"/>
               </a:spcBef>
-              <a:defRPr b="1" sz="840">
+              <a:defRPr b="1" sz="820">
                 <a:solidFill>
                   <a:srgbClr val="2563EB"/>
                 </a:solidFill>
               </a:defRPr>
             </a:pPr>
             <a:r>
-              <a:t>• 1. Thách đấu PPT Adversary (Goldwasser-Micali 1984 [Ref 33,34]):</a:t>
+              <a:t>• Game 2: Chống kẻ tấn công đường truyền mạng (Dolev–Yao Adversary):</a:t>
             </a:r>
           </a:p>
           <a:p>
@@ -6543,14 +6575,26 @@
               <a:spcBef>
                 <a:spcPts val="150"/>
               </a:spcBef>
-              <a:defRPr sz="760">
+              <a:defRPr sz="740">
                 <a:solidFill>
                   <a:srgbClr val="0F172A"/>
                 </a:solidFill>
               </a:defRPr>
             </a:pPr>
             <a:r>
-              <a:t>Đối chiếu: Mục 4 Trang 7. Lợi thế Adv(A) = 0.0 &lt;= 2^-128. Thử thách 50 lượt ngẫu nhiên: Kẻ thù thắng 0/50 (0.0%).</a:t>
+              <a:t>1. Ý nghĩa: Kẻ tấn công có quyền nghe lén, chặn, sửa đổi hoặc thay thế gói tin truyền giữa Server và Client.</a:t>
+            </a:r>
+            <a:br/>
+            <a:r>
+              <a:t>2. Cách tấn công: (1) Sửa nội dung tệp; (2) Thay đổi mã băm trong Proof; (3) Tráo đường dẫn tệp.</a:t>
+            </a:r>
+            <a:br/>
+            <a:r>
+              <a:t>3. Cách phòng thủ: Client lưu Root Hash tin cậy; tự băm tệp và lần ngược lên Root Hash theo chuỗi Proof.</a:t>
+            </a:r>
+            <a:br/>
+            <a:r>
+              <a:t>4. Kết quả: Phát hiện chính xác 100% mọi hành vi can thiệp làm sai lệch Root Hash.</a:t>
             </a:r>
           </a:p>
           <a:p>
@@ -6558,14 +6602,14 @@
               <a:spcBef>
                 <a:spcPts val="500"/>
               </a:spcBef>
-              <a:defRPr b="1" sz="840">
+              <a:defRPr b="1" sz="820">
                 <a:solidFill>
                   <a:srgbClr val="2563EB"/>
                 </a:solidFill>
               </a:defRPr>
             </a:pPr>
             <a:r>
-              <a:t>• 2. Kẻ tấn công Mạng Dolev-Yao (Dolev-Yao 1983 [Ref 52]):</a:t>
+              <a:t>• Game 3: Chống giả mạo nút lá và nút nhánh (Second-Preimage &amp; Domain Separation):</a:t>
             </a:r>
           </a:p>
           <a:p>
@@ -6573,14 +6617,26 @@
               <a:spcBef>
                 <a:spcPts val="150"/>
               </a:spcBef>
-              <a:defRPr sz="760">
+              <a:defRPr sz="740">
                 <a:solidFill>
                   <a:srgbClr val="0F172A"/>
                 </a:solidFill>
               </a:defRPr>
             </a:pPr>
             <a:r>
-              <a:t>Đối chiếu: Mục 4 Trang 8. Chặn đứng 100% cả 3 kịch bản can thiệp: Đổi gói tin, Tráo bằng chứng và Tấn công phát lại.</a:t>
+              <a:t>1. Ý nghĩa: Merkle Tree gồm nút lá (tệp dữ liệu) và nút nhánh (ghép băm); nếu không tách biệt sẽ bị đánh tráo.</a:t>
+            </a:r>
+            <a:br/>
+            <a:r>
+              <a:t>2. Cách tấn công: Tạo tệp chứa chuỗi ghép Left || Right nhằm lừa hệ thống coi tệp rác là một nút lá.</a:t>
+            </a:r>
+            <a:br/>
+            <a:r>
+              <a:t>3. Cách phòng thủ: Chuẩn RFC 6962: H_leaf = SHA256(0x00 || Data), H_branch = SHA256(0x01 || L || R).</a:t>
+            </a:r>
+            <a:br/>
+            <a:r>
+              <a:t>4. Kết quả: Hai miền tiền tố độc lập hoàn toàn, triệt tiêu 100% việc nhầm lẫn giữa lá và nhánh.</a:t>
             </a:r>
           </a:p>
           <a:p>
@@ -6588,14 +6644,14 @@
               <a:spcBef>
                 <a:spcPts val="500"/>
               </a:spcBef>
-              <a:defRPr b="1" sz="840">
+              <a:defRPr b="1" sz="820">
                 <a:solidFill>
                   <a:srgbClr val="2563EB"/>
                 </a:solidFill>
               </a:defRPr>
             </a:pPr>
             <a:r>
-              <a:t>• 3. Kháng Va chạm Second-Preimage RFC 6962 [Ref 109]:</a:t>
+              <a:t>• Game 4: Kiểm tra hiệu ứng tuyết lở (Avalanche Effect):</a:t>
             </a:r>
           </a:p>
           <a:p>
@@ -6603,134 +6659,26 @@
               <a:spcBef>
                 <a:spcPts val="150"/>
               </a:spcBef>
-              <a:defRPr sz="760">
+              <a:defRPr sz="740">
                 <a:solidFill>
                   <a:srgbClr val="0F172A"/>
                 </a:solidFill>
               </a:defRPr>
             </a:pPr>
             <a:r>
-              <a:t>Đối chiếu: Mục 5 Trang 8-10. Tiền tố 0x00 lá và 0x01 nhánh triệt tiêu 100% nguy cơ tráo lá thành nhánh.</a:t>
-            </a:r>
-          </a:p>
-          <a:p>
-            <a:pPr>
-              <a:spcBef>
-                <a:spcPts val="500"/>
-              </a:spcBef>
-              <a:defRPr b="1" sz="840">
-                <a:solidFill>
-                  <a:srgbClr val="2563EB"/>
-                </a:solidFill>
-              </a:defRPr>
-            </a:pPr>
-            <a:r>
-              <a:t>• 4. Bằng chứng Nhất quán RFC 6962 Consistency Proof [Ref 109]:</a:t>
-            </a:r>
-          </a:p>
-          <a:p>
-            <a:pPr>
-              <a:spcBef>
-                <a:spcPts val="150"/>
-              </a:spcBef>
-              <a:defRPr sz="760">
-                <a:solidFill>
-                  <a:srgbClr val="0F172A"/>
-                </a:solidFill>
-              </a:defRPr>
-            </a:pPr>
-            <a:r>
-              <a:t>Đối chiếu: Mục 6 Trang 11-14. Bằng chứng 10 nút (320 byte) chứng minh kho dữ liệu là append-only, chống chèn backdoor 100%.</a:t>
-            </a:r>
-          </a:p>
-          <a:p>
-            <a:pPr>
-              <a:spcBef>
-                <a:spcPts val="500"/>
-              </a:spcBef>
-              <a:defRPr b="1" sz="840">
-                <a:solidFill>
-                  <a:srgbClr val="2563EB"/>
-                </a:solidFill>
-              </a:defRPr>
-            </a:pPr>
-            <a:r>
-              <a:t>• 5. Xấp xỉ Random Oracle &amp; Hiệu ứng Tuyết lở (SAC) [Ref 40]:</a:t>
-            </a:r>
-          </a:p>
-          <a:p>
-            <a:pPr>
-              <a:spcBef>
-                <a:spcPts val="150"/>
-              </a:spcBef>
-              <a:defRPr sz="760">
-                <a:solidFill>
-                  <a:srgbClr val="0F172A"/>
-                </a:solidFill>
-              </a:defRPr>
-            </a:pPr>
-            <a:r>
-              <a:t>Đối chiếu: Mục 1-2 &amp; 4. SAC = 51.95% ≈ 50%, áp đảo tính tuyến tính dễ bị bẻ gãy của mã CRC32.</a:t>
-            </a:r>
-          </a:p>
-          <a:p>
-            <a:pPr>
-              <a:spcBef>
-                <a:spcPts val="500"/>
-              </a:spcBef>
-              <a:defRPr b="1" sz="840">
-                <a:solidFill>
-                  <a:srgbClr val="2563EB"/>
-                </a:solidFill>
-              </a:defRPr>
-            </a:pPr>
-            <a:r>
-              <a:t>• 6. Mô hình Toàn vẹn Phân cấp Biba (Biba 1977 [Ref 21]):</a:t>
-            </a:r>
-          </a:p>
-          <a:p>
-            <a:pPr>
-              <a:spcBef>
-                <a:spcPts val="150"/>
-              </a:spcBef>
-              <a:defRPr sz="760">
-                <a:solidFill>
-                  <a:srgbClr val="0F172A"/>
-                </a:solidFill>
-              </a:defRPr>
-            </a:pPr>
-            <a:r>
-              <a:t>Đối chiếu: Mục 3 Trang 4-5. Tiên đề No write-up: Sai khác tệp lá phản xạ tức thì làm đổi Root Hash trong 0.13 ms.</a:t>
-            </a:r>
-          </a:p>
-          <a:p>
-            <a:pPr>
-              <a:spcBef>
-                <a:spcPts val="500"/>
-              </a:spcBef>
-              <a:defRPr b="1" sz="840">
-                <a:solidFill>
-                  <a:srgbClr val="2563EB"/>
-                </a:solidFill>
-              </a:defRPr>
-            </a:pPr>
-            <a:r>
-              <a:t>• 7. Bảo vệ Siêu dữ liệu &amp; Kháng Kênh kề Đo thời gian [Ref 36, 100]:</a:t>
-            </a:r>
-          </a:p>
-          <a:p>
-            <a:pPr>
-              <a:spcBef>
-                <a:spcPts val="150"/>
-              </a:spcBef>
-              <a:defRPr sz="760">
-                <a:solidFill>
-                  <a:srgbClr val="0F172A"/>
-                </a:solidFill>
-              </a:defRPr>
-            </a:pPr>
-            <a:r>
-              <a:t>Đối chiếu: Mục 5-6. Tiết lộ 0/1000 tên tệp; dùng hàm hmac.compare_digest triệt tiêu rò rỉ kênh kề O(1); xóa an toàn RAM.</a:t>
+              <a:t>1. Ý nghĩa: Thay đổi một phần rất nhỏ đầu vào thì mã băm đầu ra phải biến đổi ngẫu nhiên rất mạnh.</a:t>
+            </a:r>
+            <a:br/>
+            <a:r>
+              <a:t>2. Cách tấn công: Đảo 1 bit trong tệp rồi so sánh mã băm trước và sau để dò tìm quy luật tương quan.</a:t>
+            </a:r>
+            <a:br/>
+            <a:r>
+              <a:t>3. Cách phòng thủ: Đo khoảng cách Hamming; tỷ lệ bit thay đổi kỳ vọng xấp xỉ 50% (Shannon Diffusion).</a:t>
+            </a:r>
+            <a:br/>
+            <a:r>
+              <a:t>4. Kết quả: Thực nghiệm đo được 50.39% ≈ 50%, phù hợp hoàn hảo với đặc tính khuếch tán của SHA-256.</a:t>
             </a:r>
           </a:p>
         </p:txBody>
@@ -6743,8 +6691,8 @@
         </p:nvSpPr>
         <p:spPr>
           <a:xfrm>
-            <a:off x="6035040" y="1234440"/>
-            <a:ext cx="5394960" cy="5257800"/>
+            <a:off x="6217920" y="1234440"/>
+            <a:ext cx="5212080" cy="5257800"/>
           </a:xfrm>
           <a:prstGeom prst="roundRect">
             <a:avLst/>
@@ -6788,8 +6736,8 @@
         </p:nvSpPr>
         <p:spPr>
           <a:xfrm>
-            <a:off x="6263640" y="1463040"/>
-            <a:ext cx="4937760" cy="4800600"/>
+            <a:off x="6446520" y="1463040"/>
+            <a:ext cx="4754880" cy="4800600"/>
           </a:xfrm>
           <a:prstGeom prst="rect">
             <a:avLst/>
@@ -6828,7 +6776,7 @@
               </a:defRPr>
             </a:pPr>
             <a:r>
-              <a:t>Sơ Đồ 7 Mô Hình Kiểm Định An Toàn Toán Học</a:t>
+              <a:t>Sơ Đồ Mô Phỏng 4 Trò Chơi An Ninh Toán Học (Games 1 – 4)</a:t>
             </a:r>
           </a:p>
           <a:p>
@@ -6855,7 +6803,7 @@
               </a:defRPr>
             </a:pPr>
             <a:r>
-              <a:t>• Thiết kế lưới 7 khối thẻ đại diện cho 7 mô hình toán học trong bài báo:</a:t>
+              <a:t>• Khối 1 (PPT Adversary): Không gian băm 2^256, Birthday Bound 2^128 triệt tiêu va chạm.</a:t>
             </a:r>
           </a:p>
           <a:p>
@@ -6870,7 +6818,7 @@
               </a:defRPr>
             </a:pPr>
             <a:r>
-              <a:t>• 1. Thách đấu PPT Adversary (Advantage = 0.0 &lt;= 2^-128).</a:t>
+              <a:t>• Khối 2 (Dolev-Yao Network): Luồng Server -&gt; Mạng (Bị can thiệp) -&gt; Client đối chiếu Root Hash tin cậy.</a:t>
             </a:r>
           </a:p>
           <a:p>
@@ -6885,7 +6833,7 @@
               </a:defRPr>
             </a:pPr>
             <a:r>
-              <a:t>• 2. Kẻ tấn công mạng Dolev-Yao (Chặn 100% Tamper, Swap, Replay).</a:t>
+              <a:t>• Khối 3 (Domain Separation): Minh họa nút lá tiền tố 0x00 (màu cam) vs nút nhánh 0x01 (màu xanh).</a:t>
             </a:r>
           </a:p>
           <a:p>
@@ -6900,7 +6848,7 @@
               </a:defRPr>
             </a:pPr>
             <a:r>
-              <a:t>• 3. Kháng Second-Preimage RFC 6962 (Domain Separation).</a:t>
+              <a:t>• Khối 4 (Avalanche Effect): Đồ thị phân phối 1 bit đảo -&gt; 129/256 bit đầu ra biến đổi ngẫu nhiên (50.39%).</a:t>
             </a:r>
           </a:p>
           <a:p>
@@ -6915,52 +6863,7 @@
               </a:defRPr>
             </a:pPr>
             <a:r>
-              <a:t>• 4. Bằng chứng nhất quán RFC 6962 (Append-Only Consistency Proof).</a:t>
-            </a:r>
-          </a:p>
-          <a:p>
-            <a:pPr>
-              <a:spcBef>
-                <a:spcPts val="300"/>
-              </a:spcBef>
-              <a:defRPr sz="880">
-                <a:solidFill>
-                  <a:srgbClr val="0F172A"/>
-                </a:solidFill>
-              </a:defRPr>
-            </a:pPr>
-            <a:r>
-              <a:t>• 5. Xấp xỉ Random Oracle &amp; Hiệu ứng tuyết lở SHA-256 (SAC 51.95%).</a:t>
-            </a:r>
-          </a:p>
-          <a:p>
-            <a:pPr>
-              <a:spcBef>
-                <a:spcPts val="300"/>
-              </a:spcBef>
-              <a:defRPr sz="880">
-                <a:solidFill>
-                  <a:srgbClr val="0F172A"/>
-                </a:solidFill>
-              </a:defRPr>
-            </a:pPr>
-            <a:r>
-              <a:t>• 6. Toàn vẹn phân cấp Biba (Biba Integrity Model 1977).</a:t>
-            </a:r>
-          </a:p>
-          <a:p>
-            <a:pPr>
-              <a:spcBef>
-                <a:spcPts val="300"/>
-              </a:spcBef>
-              <a:defRPr sz="880">
-                <a:solidFill>
-                  <a:srgbClr val="0F172A"/>
-                </a:solidFill>
-              </a:defRPr>
-            </a:pPr>
-            <a:r>
-              <a:t>• 7. Kháng rò rỉ siêu dữ liệu &amp; Kháng kênh kề đo thời gian (Kocher 1996).</a:t>
+              <a:t>• Vẽ các mũi tên trạng thái kiểm định toán học chuyển tiếp tuần tự từ Game 1 đến Game 4.</a:t>
             </a:r>
           </a:p>
         </p:txBody>
@@ -7103,7 +7006,7 @@
               </a:defRPr>
             </a:pPr>
             <a:r>
-              <a:t>PHẦN 5: TRÌNH DIỄN THỰC TẾ VÀ TỔNG KẾT</a:t>
+              <a:t>PHẦN 4C: TRỤ CỘT II - MÔ PHỎNG AN NINH HÌNH THỨC (HƯỚNG 2)</a:t>
             </a:r>
           </a:p>
         </p:txBody>
@@ -7138,7 +7041,7 @@
               </a:defRPr>
             </a:pPr>
             <a:r>
-              <a:t>14. Kịch Bản Thao Tác Trình Diễn Trên Giao Diện Web Trực Quan</a:t>
+              <a:t>14. Khung 7 Trò Chơi An Ninh Mật Mã Học (Games 5 – 7 &amp; Bảng Tổng Kết)</a:t>
             </a:r>
           </a:p>
         </p:txBody>
@@ -7152,7 +7055,7 @@
         <p:spPr>
           <a:xfrm>
             <a:off x="731520" y="1234440"/>
-            <a:ext cx="5120640" cy="5257800"/>
+            <a:ext cx="5029200" cy="5257800"/>
           </a:xfrm>
           <a:prstGeom prst="roundRect">
             <a:avLst/>
@@ -7197,7 +7100,7 @@
         <p:spPr>
           <a:xfrm>
             <a:off x="960120" y="1399032"/>
-            <a:ext cx="4663440" cy="4965192"/>
+            <a:ext cx="4572000" cy="4965192"/>
           </a:xfrm>
           <a:prstGeom prst="rect">
             <a:avLst/>
@@ -7218,7 +7121,7 @@
               </a:defRPr>
             </a:pPr>
             <a:r>
-              <a:t>Các Bước Thao Tác Trình Diễn Trước Hội Đồng</a:t>
+              <a:t>Ba Mô Hình Kiểm Định Nâng Cao (Games 5 – 7)</a:t>
             </a:r>
           </a:p>
           <a:p>
@@ -7226,14 +7129,14 @@
               <a:spcBef>
                 <a:spcPts val="500"/>
               </a:spcBef>
-              <a:defRPr b="1" sz="1030">
+              <a:defRPr b="1" sz="820">
                 <a:solidFill>
                   <a:srgbClr val="2563EB"/>
                 </a:solidFill>
               </a:defRPr>
             </a:pPr>
             <a:r>
-              <a:t>• Khởi động hệ thống nhanh chóng:</a:t>
+              <a:t>• Game 5: Bảo vệ tính nhất quán lịch sử (Append-Only Consistency Proof):</a:t>
             </a:r>
           </a:p>
           <a:p>
@@ -7241,14 +7144,26 @@
               <a:spcBef>
                 <a:spcPts val="150"/>
               </a:spcBef>
-              <a:defRPr sz="950">
+              <a:defRPr sz="740">
                 <a:solidFill>
                   <a:srgbClr val="0F172A"/>
                 </a:solidFill>
               </a:defRPr>
             </a:pPr>
             <a:r>
-              <a:t>Chỉ cần nhấp đúp tệp run_demo_web.bat trên màn hình máy tính. Trình duyệt web sẽ tự động mở trang điều khiển tại địa chỉ nội bộ http://127.0.0.1:8080.</a:t>
+              <a:t>1. Ý nghĩa: Kiểm tra dữ liệu cũ có được giữ nguyên khi hệ thống bổ sung dữ liệu mới hay không.</a:t>
+            </a:r>
+            <a:br/>
+            <a:r>
+              <a:t>2. Cách tấn công: Server sửa 1 tệp cũ trong 950 tệp, thêm 50 tệp mới thành 1.000 tệp rồi tuyên bố lịch sử nguyên vẹn.</a:t>
+            </a:r>
+            <a:br/>
+            <a:r>
+              <a:t>3. Cách phòng thủ: Consistency Proof RFC 6962 chứng minh cây cũ m=950 là tiền tố bất biến của cây mới n=1.000.</a:t>
+            </a:r>
+            <a:br/>
+            <a:r>
+              <a:t>4. Kết quả: Nếu dữ liệu cũ bị sửa, bằng chứng nhất quán bị từ chối ngay lập tức.</a:t>
             </a:r>
           </a:p>
           <a:p>
@@ -7256,14 +7171,14 @@
               <a:spcBef>
                 <a:spcPts val="500"/>
               </a:spcBef>
-              <a:defRPr b="1" sz="1030">
+              <a:defRPr b="1" sz="820">
                 <a:solidFill>
                   <a:srgbClr val="2563EB"/>
                 </a:solidFill>
               </a:defRPr>
             </a:pPr>
             <a:r>
-              <a:t>• Bước 1: Nạp 1.000 tệp tin dữ liệu gốc ban đầu:</a:t>
+              <a:t>• Game 6: Chống trích xuất dữ liệu nhạy cảm từ RAM (Memory-Dump Adversary):</a:t>
             </a:r>
           </a:p>
           <a:p>
@@ -7271,14 +7186,26 @@
               <a:spcBef>
                 <a:spcPts val="150"/>
               </a:spcBef>
-              <a:defRPr sz="950">
+              <a:defRPr sz="740">
                 <a:solidFill>
                   <a:srgbClr val="0F172A"/>
                 </a:solidFill>
               </a:defRPr>
             </a:pPr>
             <a:r>
-              <a:t>Nhấp nút Nạp dữ liệu để hệ thống quét toàn bộ 1.000 tệp tin nguyên bản từ thư mục realistic_dataset và tạo chuỗi băm gốc 32 byte.</a:t>
+              <a:t>1. Ý nghĩa: Kẻ tấn công đọc trộm RAM sau khi chương trình chạy để tìm khóa bí mật hoặc dữ liệu nhạy cảm.</a:t>
+            </a:r>
+            <a:br/>
+            <a:r>
+              <a:t>2. Cách tấn công: Dump bộ nhớ tiến trình và tìm kiếm khóa còn vương lại trong bộ nhớ đệm.</a:t>
+            </a:r>
+            <a:br/>
+            <a:r>
+              <a:t>3. Cách phòng thủ: Memory Zeroization: lưu khóa trong bytearray, chủ động ghi đè bằng 0x00 qua secure_erase().</a:t>
+            </a:r>
+            <a:br/>
+            <a:r>
+              <a:t>4. Lưu ý Python: gc.collect() thu hồi biến nhưng trong runtime không bảo đảm xóa sạch tuyệt đối mọi bản sao.</a:t>
             </a:r>
           </a:p>
           <a:p>
@@ -7286,14 +7213,14 @@
               <a:spcBef>
                 <a:spcPts val="500"/>
               </a:spcBef>
-              <a:defRPr b="1" sz="1030">
+              <a:defRPr b="1" sz="820">
                 <a:solidFill>
                   <a:srgbClr val="2563EB"/>
                 </a:solidFill>
               </a:defRPr>
             </a:pPr>
             <a:r>
-              <a:t>• Bước 2: Mô phỏng hành vi Kẻ tấn công mạng:</a:t>
+              <a:t>• Game 7: Chống tấn công đo thời gian &amp; Giảm rò rỉ siêu dữ liệu:</a:t>
             </a:r>
           </a:p>
           <a:p>
@@ -7301,52 +7228,18 @@
               <a:spcBef>
                 <a:spcPts val="150"/>
               </a:spcBef>
-              <a:defRPr sz="950">
+              <a:defRPr sz="740">
                 <a:solidFill>
                   <a:srgbClr val="0F172A"/>
                 </a:solidFill>
               </a:defRPr>
             </a:pPr>
             <a:r>
-              <a:t>1. Nhấp Đảo 1 bit ngẫu nhiên để mô phỏng dữ liệu bị sửa đổi ngầm.</a:t>
+              <a:t>Phần A (Timing Side-Channel): Không dùng toán tử == (dừng sớm theo ký tự sai). Sử dụng hmac.compare_digest() để thời gian so sánh chuỗi là hằng số O(1).</a:t>
             </a:r>
             <a:br/>
             <a:r>
-              <a:t>2. Nhấp Chèn tệp lạ để mô phỏng tin tặc tải mã độc lên máy chủ.</a:t>
-            </a:r>
-            <a:br/>
-            <a:r>
-              <a:t>3. Nhấp Xóa lén tệp tin để mô phỏng hành vi xóa dữ liệu phá hoại.</a:t>
-            </a:r>
-          </a:p>
-          <a:p>
-            <a:pPr>
-              <a:spcBef>
-                <a:spcPts val="500"/>
-              </a:spcBef>
-              <a:defRPr b="1" sz="1030">
-                <a:solidFill>
-                  <a:srgbClr val="2563EB"/>
-                </a:solidFill>
-              </a:defRPr>
-            </a:pPr>
-            <a:r>
-              <a:t>• Bước 3: Kiểm tra và định vị lỗi tức thì:</a:t>
-            </a:r>
-          </a:p>
-          <a:p>
-            <a:pPr>
-              <a:spcBef>
-                <a:spcPts val="150"/>
-              </a:spcBef>
-              <a:defRPr sz="950">
-                <a:solidFill>
-                  <a:srgbClr val="0F172A"/>
-                </a:solidFill>
-              </a:defRPr>
-            </a:pPr>
-            <a:r>
-              <a:t>Nhấp Chạy kiểm tra toàn vẹn. Hệ thống lập tức chỉ đúng tên tệp bị can thiệp, hiển thị tỷ lệ nguyên vẹn và tốc độ xử lý hơn 4.000 tệp mỗi giây.</a:t>
+              <a:t>Phần B (Metadata Leakage): Thay vì tải toàn bộ 111 KB manifest chứa tên 1.000 tệp, Merkle Proof chỉ gửi mã băm anh em cần thiết, bảo vệ tính riêng tư của 999 tệp còn lại.</a:t>
             </a:r>
           </a:p>
         </p:txBody>
@@ -7359,18 +7252,18 @@
         </p:nvSpPr>
         <p:spPr>
           <a:xfrm>
-            <a:off x="6035040" y="1234440"/>
-            <a:ext cx="5394960" cy="5257800"/>
+            <a:off x="5943600" y="1234440"/>
+            <a:ext cx="5486400" cy="3291840"/>
           </a:xfrm>
           <a:prstGeom prst="roundRect">
             <a:avLst/>
           </a:prstGeom>
           <a:solidFill>
-            <a:srgbClr val="F1F5F9"/>
+            <a:srgbClr val="FFFFFF"/>
           </a:solidFill>
-          <a:ln w="19050">
+          <a:ln w="15240">
             <a:solidFill>
-              <a:srgbClr val="94A3B8"/>
+              <a:srgbClr val="E2E8F0"/>
             </a:solidFill>
           </a:ln>
         </p:spPr>
@@ -7396,16 +7289,656 @@
           </a:p>
         </p:txBody>
       </p:sp>
-      <p:sp>
-        <p:nvSpPr>
-          <p:cNvPr id="9" name="TextBox 8"/>
+      <p:graphicFrame>
+        <p:nvGraphicFramePr>
+          <p:cNvPr id="9" name="Table 8"/>
+          <p:cNvGraphicFramePr>
+            <a:graphicFrameLocks noGrp="1"/>
+          </p:cNvGraphicFramePr>
+          <p:nvPr/>
+        </p:nvGraphicFramePr>
+        <p:xfrm>
+          <a:off x="6035040" y="1325880"/>
+          <a:ext cx="5303520" cy="3108960"/>
+        </p:xfrm>
+        <a:graphic>
+          <a:graphicData uri="http://schemas.openxmlformats.org/drawingml/2006/table">
+            <a:tbl>
+              <a:tblPr firstRow="1" bandRow="1">
+                <a:tableStyleId>{5C22544A-7EE6-4342-B048-85BDC9FD1C3A}</a:tableStyleId>
+              </a:tblPr>
+              <a:tblGrid>
+                <a:gridCol w="868680"/>
+                <a:gridCol w="2331720"/>
+                <a:gridCol w="2103120"/>
+              </a:tblGrid>
+              <a:tr h="388620">
+                <a:tc>
+                  <a:txBody>
+                    <a:bodyPr/>
+                    <a:lstStyle/>
+                    <a:p>
+                      <a:pPr algn="ctr">
+                        <a:defRPr b="1" sz="919">
+                          <a:solidFill>
+                            <a:srgbClr val="FFFFFF"/>
+                          </a:solidFill>
+                        </a:defRPr>
+                      </a:pPr>
+                      <a:r>
+                        <a:t>Game</a:t>
+                      </a:r>
+                    </a:p>
+                  </a:txBody>
+                  <a:tcPr>
+                    <a:solidFill>
+                      <a:srgbClr val="1E3A8A"/>
+                    </a:solidFill>
+                  </a:tcPr>
+                </a:tc>
+                <a:tc>
+                  <a:txBody>
+                    <a:bodyPr/>
+                    <a:lstStyle/>
+                    <a:p>
+                      <a:pPr algn="ctr">
+                        <a:defRPr b="1" sz="919">
+                          <a:solidFill>
+                            <a:srgbClr val="FFFFFF"/>
+                          </a:solidFill>
+                        </a:defRPr>
+                      </a:pPr>
+                      <a:r>
+                        <a:t>Mục Tiêu Bảo Mật</a:t>
+                      </a:r>
+                    </a:p>
+                  </a:txBody>
+                  <a:tcPr>
+                    <a:solidFill>
+                      <a:srgbClr val="1E3A8A"/>
+                    </a:solidFill>
+                  </a:tcPr>
+                </a:tc>
+                <a:tc>
+                  <a:txBody>
+                    <a:bodyPr/>
+                    <a:lstStyle/>
+                    <a:p>
+                      <a:pPr algn="ctr">
+                        <a:defRPr b="1" sz="919">
+                          <a:solidFill>
+                            <a:srgbClr val="FFFFFF"/>
+                          </a:solidFill>
+                        </a:defRPr>
+                      </a:pPr>
+                      <a:r>
+                        <a:t>Cơ Chế Chính Triển Khai</a:t>
+                      </a:r>
+                    </a:p>
+                  </a:txBody>
+                  <a:tcPr>
+                    <a:solidFill>
+                      <a:srgbClr val="1E3A8A"/>
+                    </a:solidFill>
+                  </a:tcPr>
+                </a:tc>
+              </a:tr>
+              <a:tr h="388620">
+                <a:tc>
+                  <a:txBody>
+                    <a:bodyPr/>
+                    <a:lstStyle/>
+                    <a:p>
+                      <a:pPr algn="ctr">
+                        <a:defRPr sz="819" b="1">
+                          <a:solidFill>
+                            <a:srgbClr val="2563EB"/>
+                          </a:solidFill>
+                        </a:defRPr>
+                      </a:pPr>
+                      <a:r>
+                        <a:t>Game 1</a:t>
+                      </a:r>
+                    </a:p>
+                  </a:txBody>
+                  <a:tcPr>
+                    <a:solidFill>
+                      <a:srgbClr val="F8FAFC"/>
+                    </a:solidFill>
+                  </a:tcPr>
+                </a:tc>
+                <a:tc>
+                  <a:txBody>
+                    <a:bodyPr/>
+                    <a:lstStyle/>
+                    <a:p>
+                      <a:pPr>
+                        <a:defRPr sz="819">
+                          <a:solidFill>
+                            <a:srgbClr val="0F172A"/>
+                          </a:solidFill>
+                        </a:defRPr>
+                      </a:pPr>
+                      <a:r>
+                        <a:t>Chống tìm hai dữ liệu cùng mã băm</a:t>
+                      </a:r>
+                    </a:p>
+                  </a:txBody>
+                  <a:tcPr>
+                    <a:solidFill>
+                      <a:srgbClr val="F8FAFC"/>
+                    </a:solidFill>
+                  </a:tcPr>
+                </a:tc>
+                <a:tc>
+                  <a:txBody>
+                    <a:bodyPr/>
+                    <a:lstStyle/>
+                    <a:p>
+                      <a:pPr>
+                        <a:defRPr sz="819">
+                          <a:solidFill>
+                            <a:srgbClr val="0F172A"/>
+                          </a:solidFill>
+                        </a:defRPr>
+                      </a:pPr>
+                      <a:r>
+                        <a:t>SHA-256 (Adv &lt;= 2^-128)</a:t>
+                      </a:r>
+                    </a:p>
+                  </a:txBody>
+                  <a:tcPr>
+                    <a:solidFill>
+                      <a:srgbClr val="F8FAFC"/>
+                    </a:solidFill>
+                  </a:tcPr>
+                </a:tc>
+              </a:tr>
+              <a:tr h="388620">
+                <a:tc>
+                  <a:txBody>
+                    <a:bodyPr/>
+                    <a:lstStyle/>
+                    <a:p>
+                      <a:pPr algn="ctr">
+                        <a:defRPr sz="819" b="1">
+                          <a:solidFill>
+                            <a:srgbClr val="2563EB"/>
+                          </a:solidFill>
+                        </a:defRPr>
+                      </a:pPr>
+                      <a:r>
+                        <a:t>Game 2</a:t>
+                      </a:r>
+                    </a:p>
+                  </a:txBody>
+                  <a:tcPr>
+                    <a:solidFill>
+                      <a:srgbClr val="FFFFFF"/>
+                    </a:solidFill>
+                  </a:tcPr>
+                </a:tc>
+                <a:tc>
+                  <a:txBody>
+                    <a:bodyPr/>
+                    <a:lstStyle/>
+                    <a:p>
+                      <a:pPr>
+                        <a:defRPr sz="819">
+                          <a:solidFill>
+                            <a:srgbClr val="0F172A"/>
+                          </a:solidFill>
+                        </a:defRPr>
+                      </a:pPr>
+                      <a:r>
+                        <a:t>Phát hiện dữ liệu bị sửa khi truyền</a:t>
+                      </a:r>
+                    </a:p>
+                  </a:txBody>
+                  <a:tcPr>
+                    <a:solidFill>
+                      <a:srgbClr val="FFFFFF"/>
+                    </a:solidFill>
+                  </a:tcPr>
+                </a:tc>
+                <a:tc>
+                  <a:txBody>
+                    <a:bodyPr/>
+                    <a:lstStyle/>
+                    <a:p>
+                      <a:pPr>
+                        <a:defRPr sz="819">
+                          <a:solidFill>
+                            <a:srgbClr val="0F172A"/>
+                          </a:solidFill>
+                        </a:defRPr>
+                      </a:pPr>
+                      <a:r>
+                        <a:t>Merkle Proof + Root Hash tin cậy</a:t>
+                      </a:r>
+                    </a:p>
+                  </a:txBody>
+                  <a:tcPr>
+                    <a:solidFill>
+                      <a:srgbClr val="FFFFFF"/>
+                    </a:solidFill>
+                  </a:tcPr>
+                </a:tc>
+              </a:tr>
+              <a:tr h="388620">
+                <a:tc>
+                  <a:txBody>
+                    <a:bodyPr/>
+                    <a:lstStyle/>
+                    <a:p>
+                      <a:pPr algn="ctr">
+                        <a:defRPr sz="819" b="1">
+                          <a:solidFill>
+                            <a:srgbClr val="2563EB"/>
+                          </a:solidFill>
+                        </a:defRPr>
+                      </a:pPr>
+                      <a:r>
+                        <a:t>Game 3</a:t>
+                      </a:r>
+                    </a:p>
+                  </a:txBody>
+                  <a:tcPr>
+                    <a:solidFill>
+                      <a:srgbClr val="F8FAFC"/>
+                    </a:solidFill>
+                  </a:tcPr>
+                </a:tc>
+                <a:tc>
+                  <a:txBody>
+                    <a:bodyPr/>
+                    <a:lstStyle/>
+                    <a:p>
+                      <a:pPr>
+                        <a:defRPr sz="819">
+                          <a:solidFill>
+                            <a:srgbClr val="0F172A"/>
+                          </a:solidFill>
+                        </a:defRPr>
+                      </a:pPr>
+                      <a:r>
+                        <a:t>Phân biệt nút lá và nút nhánh</a:t>
+                      </a:r>
+                    </a:p>
+                  </a:txBody>
+                  <a:tcPr>
+                    <a:solidFill>
+                      <a:srgbClr val="F8FAFC"/>
+                    </a:solidFill>
+                  </a:tcPr>
+                </a:tc>
+                <a:tc>
+                  <a:txBody>
+                    <a:bodyPr/>
+                    <a:lstStyle/>
+                    <a:p>
+                      <a:pPr>
+                        <a:defRPr sz="819">
+                          <a:solidFill>
+                            <a:srgbClr val="0F172A"/>
+                          </a:solidFill>
+                        </a:defRPr>
+                      </a:pPr>
+                      <a:r>
+                        <a:t>Domain Separation (0x00 / 0x01)</a:t>
+                      </a:r>
+                    </a:p>
+                  </a:txBody>
+                  <a:tcPr>
+                    <a:solidFill>
+                      <a:srgbClr val="F8FAFC"/>
+                    </a:solidFill>
+                  </a:tcPr>
+                </a:tc>
+              </a:tr>
+              <a:tr h="388620">
+                <a:tc>
+                  <a:txBody>
+                    <a:bodyPr/>
+                    <a:lstStyle/>
+                    <a:p>
+                      <a:pPr algn="ctr">
+                        <a:defRPr sz="819" b="1">
+                          <a:solidFill>
+                            <a:srgbClr val="2563EB"/>
+                          </a:solidFill>
+                        </a:defRPr>
+                      </a:pPr>
+                      <a:r>
+                        <a:t>Game 4</a:t>
+                      </a:r>
+                    </a:p>
+                  </a:txBody>
+                  <a:tcPr>
+                    <a:solidFill>
+                      <a:srgbClr val="FFFFFF"/>
+                    </a:solidFill>
+                  </a:tcPr>
+                </a:tc>
+                <a:tc>
+                  <a:txBody>
+                    <a:bodyPr/>
+                    <a:lstStyle/>
+                    <a:p>
+                      <a:pPr>
+                        <a:defRPr sz="819">
+                          <a:solidFill>
+                            <a:srgbClr val="0F172A"/>
+                          </a:solidFill>
+                        </a:defRPr>
+                      </a:pPr>
+                      <a:r>
+                        <a:t>Kiểm tra mức độ thay đổi mã băm</a:t>
+                      </a:r>
+                    </a:p>
+                  </a:txBody>
+                  <a:tcPr>
+                    <a:solidFill>
+                      <a:srgbClr val="FFFFFF"/>
+                    </a:solidFill>
+                  </a:tcPr>
+                </a:tc>
+                <a:tc>
+                  <a:txBody>
+                    <a:bodyPr/>
+                    <a:lstStyle/>
+                    <a:p>
+                      <a:pPr>
+                        <a:defRPr sz="819">
+                          <a:solidFill>
+                            <a:srgbClr val="0F172A"/>
+                          </a:solidFill>
+                        </a:defRPr>
+                      </a:pPr>
+                      <a:r>
+                        <a:t>Avalanche Effect (50.39% ≈ 50%)</a:t>
+                      </a:r>
+                    </a:p>
+                  </a:txBody>
+                  <a:tcPr>
+                    <a:solidFill>
+                      <a:srgbClr val="FFFFFF"/>
+                    </a:solidFill>
+                  </a:tcPr>
+                </a:tc>
+              </a:tr>
+              <a:tr h="388620">
+                <a:tc>
+                  <a:txBody>
+                    <a:bodyPr/>
+                    <a:lstStyle/>
+                    <a:p>
+                      <a:pPr algn="ctr">
+                        <a:defRPr sz="819" b="1">
+                          <a:solidFill>
+                            <a:srgbClr val="2563EB"/>
+                          </a:solidFill>
+                        </a:defRPr>
+                      </a:pPr>
+                      <a:r>
+                        <a:t>Game 5</a:t>
+                      </a:r>
+                    </a:p>
+                  </a:txBody>
+                  <a:tcPr>
+                    <a:solidFill>
+                      <a:srgbClr val="F8FAFC"/>
+                    </a:solidFill>
+                  </a:tcPr>
+                </a:tc>
+                <a:tc>
+                  <a:txBody>
+                    <a:bodyPr/>
+                    <a:lstStyle/>
+                    <a:p>
+                      <a:pPr>
+                        <a:defRPr sz="819">
+                          <a:solidFill>
+                            <a:srgbClr val="0F172A"/>
+                          </a:solidFill>
+                        </a:defRPr>
+                      </a:pPr>
+                      <a:r>
+                        <a:t>Kiểm tra nhất quán qua các lần cập nhật</a:t>
+                      </a:r>
+                    </a:p>
+                  </a:txBody>
+                  <a:tcPr>
+                    <a:solidFill>
+                      <a:srgbClr val="F8FAFC"/>
+                    </a:solidFill>
+                  </a:tcPr>
+                </a:tc>
+                <a:tc>
+                  <a:txBody>
+                    <a:bodyPr/>
+                    <a:lstStyle/>
+                    <a:p>
+                      <a:pPr>
+                        <a:defRPr sz="819">
+                          <a:solidFill>
+                            <a:srgbClr val="0F172A"/>
+                          </a:solidFill>
+                        </a:defRPr>
+                      </a:pPr>
+                      <a:r>
+                        <a:t>Consistency Proof RFC 6962</a:t>
+                      </a:r>
+                    </a:p>
+                  </a:txBody>
+                  <a:tcPr>
+                    <a:solidFill>
+                      <a:srgbClr val="F8FAFC"/>
+                    </a:solidFill>
+                  </a:tcPr>
+                </a:tc>
+              </a:tr>
+              <a:tr h="388620">
+                <a:tc>
+                  <a:txBody>
+                    <a:bodyPr/>
+                    <a:lstStyle/>
+                    <a:p>
+                      <a:pPr algn="ctr">
+                        <a:defRPr sz="819" b="1">
+                          <a:solidFill>
+                            <a:srgbClr val="2563EB"/>
+                          </a:solidFill>
+                        </a:defRPr>
+                      </a:pPr>
+                      <a:r>
+                        <a:t>Game 6</a:t>
+                      </a:r>
+                    </a:p>
+                  </a:txBody>
+                  <a:tcPr>
+                    <a:solidFill>
+                      <a:srgbClr val="FFFFFF"/>
+                    </a:solidFill>
+                  </a:tcPr>
+                </a:tc>
+                <a:tc>
+                  <a:txBody>
+                    <a:bodyPr/>
+                    <a:lstStyle/>
+                    <a:p>
+                      <a:pPr>
+                        <a:defRPr sz="819">
+                          <a:solidFill>
+                            <a:srgbClr val="0F172A"/>
+                          </a:solidFill>
+                        </a:defRPr>
+                      </a:pPr>
+                      <a:r>
+                        <a:t>Hạn chế dữ liệu nhạy cảm trong RAM</a:t>
+                      </a:r>
+                    </a:p>
+                  </a:txBody>
+                  <a:tcPr>
+                    <a:solidFill>
+                      <a:srgbClr val="FFFFFF"/>
+                    </a:solidFill>
+                  </a:tcPr>
+                </a:tc>
+                <a:tc>
+                  <a:txBody>
+                    <a:bodyPr/>
+                    <a:lstStyle/>
+                    <a:p>
+                      <a:pPr>
+                        <a:defRPr sz="819">
+                          <a:solidFill>
+                            <a:srgbClr val="0F172A"/>
+                          </a:solidFill>
+                        </a:defRPr>
+                      </a:pPr>
+                      <a:r>
+                        <a:t>Memory Zeroization (secure_erase)</a:t>
+                      </a:r>
+                    </a:p>
+                  </a:txBody>
+                  <a:tcPr>
+                    <a:solidFill>
+                      <a:srgbClr val="FFFFFF"/>
+                    </a:solidFill>
+                  </a:tcPr>
+                </a:tc>
+              </a:tr>
+              <a:tr h="388620">
+                <a:tc>
+                  <a:txBody>
+                    <a:bodyPr/>
+                    <a:lstStyle/>
+                    <a:p>
+                      <a:pPr algn="ctr">
+                        <a:defRPr sz="819" b="1">
+                          <a:solidFill>
+                            <a:srgbClr val="2563EB"/>
+                          </a:solidFill>
+                        </a:defRPr>
+                      </a:pPr>
+                      <a:r>
+                        <a:t>Game 7</a:t>
+                      </a:r>
+                    </a:p>
+                  </a:txBody>
+                  <a:tcPr>
+                    <a:solidFill>
+                      <a:srgbClr val="F8FAFC"/>
+                    </a:solidFill>
+                  </a:tcPr>
+                </a:tc>
+                <a:tc>
+                  <a:txBody>
+                    <a:bodyPr/>
+                    <a:lstStyle/>
+                    <a:p>
+                      <a:pPr>
+                        <a:defRPr sz="819">
+                          <a:solidFill>
+                            <a:srgbClr val="0F172A"/>
+                          </a:solidFill>
+                        </a:defRPr>
+                      </a:pPr>
+                      <a:r>
+                        <a:t>Giảm rò rỉ thời gian &amp; siêu dữ liệu</a:t>
+                      </a:r>
+                    </a:p>
+                  </a:txBody>
+                  <a:tcPr>
+                    <a:solidFill>
+                      <a:srgbClr val="F8FAFC"/>
+                    </a:solidFill>
+                  </a:tcPr>
+                </a:tc>
+                <a:tc>
+                  <a:txBody>
+                    <a:bodyPr/>
+                    <a:lstStyle/>
+                    <a:p>
+                      <a:pPr>
+                        <a:defRPr sz="819">
+                          <a:solidFill>
+                            <a:srgbClr val="0F172A"/>
+                          </a:solidFill>
+                        </a:defRPr>
+                      </a:pPr>
+                      <a:r>
+                        <a:t>hmac.compare_digest() + Merkle Proof</a:t>
+                      </a:r>
+                    </a:p>
+                  </a:txBody>
+                  <a:tcPr>
+                    <a:solidFill>
+                      <a:srgbClr val="F8FAFC"/>
+                    </a:solidFill>
+                  </a:tcPr>
+                </a:tc>
+              </a:tr>
+            </a:tbl>
+          </a:graphicData>
+        </a:graphic>
+      </p:graphicFrame>
+      <p:sp>
+        <p:nvSpPr>
+          <p:cNvPr id="10" name="Rounded Rectangle 9"/>
+          <p:cNvSpPr/>
+          <p:nvPr/>
+        </p:nvSpPr>
+        <p:spPr>
+          <a:xfrm>
+            <a:off x="5943600" y="4663440"/>
+            <a:ext cx="5486400" cy="1828800"/>
+          </a:xfrm>
+          <a:prstGeom prst="roundRect">
+            <a:avLst/>
+          </a:prstGeom>
+          <a:solidFill>
+            <a:srgbClr val="FFFFFF"/>
+          </a:solidFill>
+          <a:ln w="15240">
+            <a:solidFill>
+              <a:srgbClr val="E2E8F0"/>
+            </a:solidFill>
+          </a:ln>
+        </p:spPr>
+        <p:style>
+          <a:lnRef idx="1">
+            <a:schemeClr val="accent1"/>
+          </a:lnRef>
+          <a:fillRef idx="3">
+            <a:schemeClr val="accent1"/>
+          </a:fillRef>
+          <a:effectRef idx="2">
+            <a:schemeClr val="accent1"/>
+          </a:effectRef>
+          <a:fontRef idx="minor">
+            <a:schemeClr val="lt1"/>
+          </a:fontRef>
+        </p:style>
+        <p:txBody>
+          <a:bodyPr rtlCol="0" anchor="ctr"/>
+          <a:lstStyle/>
+          <a:p>
+            <a:pPr algn="ctr"/>
+          </a:p>
+        </p:txBody>
+      </p:sp>
+      <p:sp>
+        <p:nvSpPr>
+          <p:cNvPr id="11" name="TextBox 10"/>
           <p:cNvSpPr txBox="1"/>
           <p:nvPr/>
         </p:nvSpPr>
         <p:spPr>
           <a:xfrm>
-            <a:off x="6263640" y="1463040"/>
-            <a:ext cx="4937760" cy="4800600"/>
+            <a:off x="6080760" y="4736592"/>
+            <a:ext cx="5212080" cy="1691640"/>
           </a:xfrm>
           <a:prstGeom prst="rect">
             <a:avLst/>
@@ -7419,104 +7952,59 @@
           <a:lstStyle/>
           <a:p>
             <a:pPr>
-              <a:defRPr b="1" sz="1000">
-                <a:solidFill>
-                  <a:srgbClr val="2563EB"/>
-                </a:solidFill>
-              </a:defRPr>
-            </a:pPr>
-            <a:r>
-              <a:t>[ VỊ TRÍ CHÈN SƠ ĐỒ / ẢNH DRAW.IO ]</a:t>
-            </a:r>
-          </a:p>
-          <a:p>
-            <a:pPr>
-              <a:spcBef>
-                <a:spcPts val="400"/>
-              </a:spcBef>
-              <a:spcAft>
-                <a:spcPts val="800"/>
-              </a:spcAft>
-              <a:defRPr b="1" sz="1250">
+              <a:defRPr b="1" sz="950">
                 <a:solidFill>
                   <a:srgbClr val="1E3A8A"/>
                 </a:solidFill>
               </a:defRPr>
             </a:pPr>
             <a:r>
-              <a:t>Ảnh Chụp Giao Diện Phòng Thí Nghiệm Web Demo</a:t>
-            </a:r>
-          </a:p>
-          <a:p>
-            <a:pPr>
-              <a:defRPr b="1" sz="950">
-                <a:solidFill>
-                  <a:srgbClr val="64748B"/>
-                </a:solidFill>
-              </a:defRPr>
-            </a:pPr>
-            <a:r>
-              <a:t>Gợi ý các thành phần cần thiết kế trên Draw.io hoặc chèn ảnh:</a:t>
-            </a:r>
-          </a:p>
-          <a:p>
-            <a:pPr>
-              <a:spcBef>
-                <a:spcPts val="300"/>
-              </a:spcBef>
-              <a:defRPr sz="880">
+              <a:t>Lưu Ý Phương Pháp Luận Khi Báo Cáo:</a:t>
+            </a:r>
+          </a:p>
+          <a:p>
+            <a:pPr>
+              <a:spcBef>
+                <a:spcPts val="250"/>
+              </a:spcBef>
+              <a:defRPr sz="780">
                 <a:solidFill>
                   <a:srgbClr val="0F172A"/>
                 </a:solidFill>
               </a:defRPr>
             </a:pPr>
             <a:r>
-              <a:t>• Chèn ảnh chụp màn hình phòng thí nghiệm Web Demo thực tế tại http://127.0.0.1:8080.</a:t>
-            </a:r>
-          </a:p>
-          <a:p>
-            <a:pPr>
-              <a:spcBef>
-                <a:spcPts val="300"/>
-              </a:spcBef>
-              <a:defRPr sz="880">
+              <a:t>• Mục đích: 7 mô hình được xây dựng để kiểm thử các khía cạnh bảo mật đối kháng khác nhau theo luận điểm của Harry Halpin (2025).</a:t>
+            </a:r>
+          </a:p>
+          <a:p>
+            <a:pPr>
+              <a:spcBef>
+                <a:spcPts val="250"/>
+              </a:spcBef>
+              <a:defRPr sz="780">
                 <a:solidFill>
                   <a:srgbClr val="0F172A"/>
                 </a:solidFill>
               </a:defRPr>
             </a:pPr>
             <a:r>
-              <a:t>• Thể hiện 4 thẻ tab chuyển đổi mô hình (Flat SHA, HMAC, Merkle chuẩn, HD-Merkle).</a:t>
-            </a:r>
-          </a:p>
-          <a:p>
-            <a:pPr>
-              <a:spcBef>
-                <a:spcPts val="300"/>
-              </a:spcBef>
-              <a:defRPr sz="880">
+              <a:t>• Đối chiếu mã nguồn: Được triển khai và chạy độc lập qua tệp src/proposed_model/security_games.py, không gộp chung benchmark.</a:t>
+            </a:r>
+          </a:p>
+          <a:p>
+            <a:pPr>
+              <a:spcBef>
+                <a:spcPts val="250"/>
+              </a:spcBef>
+              <a:defRPr sz="780">
                 <a:solidFill>
                   <a:srgbClr val="0F172A"/>
                 </a:solidFill>
               </a:defRPr>
             </a:pPr>
             <a:r>
-              <a:t>• Thể hiện 3 nút mô phỏng tấn công màu cam (Đảo bit, Bơm tệp, Xóa tệp).</a:t>
-            </a:r>
-          </a:p>
-          <a:p>
-            <a:pPr>
-              <a:spcBef>
-                <a:spcPts val="300"/>
-              </a:spcBef>
-              <a:defRPr sz="880">
-                <a:solidFill>
-                  <a:srgbClr val="0F172A"/>
-                </a:solidFill>
-              </a:defRPr>
-            </a:pPr>
-            <a:r>
-              <a:t>• Hiển thị bảng danh sách 1.000 tệp tin và thanh trạng thái tiến trình thời gian thực.</a:t>
+              <a:t>• Đánh giá khách quan: Phân biệt rõ giữa cơ chế lý thuyết toán học và kết quả đo đạc thực nghiệm cụ thể trên môi trường Python.</a:t>
             </a:r>
           </a:p>
         </p:txBody>
@@ -7694,7 +8182,7 @@
               </a:defRPr>
             </a:pPr>
             <a:r>
-              <a:t>15. Bảng Điều Khiển Biểu Đồ Đo Đạc Trực Quan Hóa Động</a:t>
+              <a:t>15. Kịch Bản Thao Tác Trình Diễn Trên Giao Diện Web Trực Quan</a:t>
             </a:r>
           </a:p>
         </p:txBody>
@@ -7774,7 +8262,7 @@
               </a:defRPr>
             </a:pPr>
             <a:r>
-              <a:t>Trực Quan Hóa Biểu Đồ Khoa Học Hoạt Động Ngoại Tuyến</a:t>
+              <a:t>Các Bước Thao Tác Trình Diễn Trước Hội Đồng</a:t>
             </a:r>
           </a:p>
           <a:p>
@@ -7789,7 +8277,7 @@
               </a:defRPr>
             </a:pPr>
             <a:r>
-              <a:t>• Hoạt động hoàn toàn ngoại tuyến:</a:t>
+              <a:t>• Khởi động hệ thống nhanh chóng:</a:t>
             </a:r>
           </a:p>
           <a:p>
@@ -7804,7 +8292,7 @@
               </a:defRPr>
             </a:pPr>
             <a:r>
-              <a:t>Hệ thống tích hợp sẵn thư viện vẽ biểu đồ nội bộ, không cần kết nối mạng Internet vẫn hiển thị mượt mà và trực quan khi báo cáo trước hội đồng.</a:t>
+              <a:t>Chỉ cần nhấp đúp tệp run_demo_web.bat trên màn hình máy tính. Trình duyệt web sẽ tự động mở trang điều khiển tại địa chỉ nội bộ http://127.0.0.1:8080.</a:t>
             </a:r>
           </a:p>
           <a:p>
@@ -7819,7 +8307,7 @@
               </a:defRPr>
             </a:pPr>
             <a:r>
-              <a:t>• 4 Biểu đồ phân tích khoa học chuyên sâu:</a:t>
+              <a:t>• Bước 1: Nạp 1.000 tệp tin dữ liệu gốc ban đầu:</a:t>
             </a:r>
           </a:p>
           <a:p>
@@ -7834,19 +8322,45 @@
               </a:defRPr>
             </a:pPr>
             <a:r>
-              <a:t>1. Biểu đồ so sánh thời gian khởi tạo và xác minh của 4 mô hình trên 1.000 tệp tin.</a:t>
+              <a:t>Nhấp nút Nạp dữ liệu để hệ thống quét toàn bộ 1.000 tệp tin nguyên bản từ thư mục realistic_dataset và tạo chuỗi băm gốc 32 byte.</a:t>
+            </a:r>
+          </a:p>
+          <a:p>
+            <a:pPr>
+              <a:spcBef>
+                <a:spcPts val="500"/>
+              </a:spcBef>
+              <a:defRPr b="1" sz="1030">
+                <a:solidFill>
+                  <a:srgbClr val="2563EB"/>
+                </a:solidFill>
+              </a:defRPr>
+            </a:pPr>
+            <a:r>
+              <a:t>• Bước 2: Mô phỏng hành vi Kẻ tấn công mạng:</a:t>
+            </a:r>
+          </a:p>
+          <a:p>
+            <a:pPr>
+              <a:spcBef>
+                <a:spcPts val="150"/>
+              </a:spcBef>
+              <a:defRPr sz="950">
+                <a:solidFill>
+                  <a:srgbClr val="0F172A"/>
+                </a:solidFill>
+              </a:defRPr>
+            </a:pPr>
+            <a:r>
+              <a:t>1. Nhấp Đảo 1 bit ngẫu nhiên để mô phỏng dữ liệu bị sửa đổi ngầm.</a:t>
             </a:r>
             <a:br/>
             <a:r>
-              <a:t>2. Biểu đồ chi phí cập nhật khi sửa 1 tệp tin phản hồi tức thì theo chiều cao cây.</a:t>
+              <a:t>2. Nhấp Chèn tệp lạ để mô phỏng tin tặc tải mã độc lên máy chủ.</a:t>
             </a:r>
             <a:br/>
             <a:r>
-              <a:t>3. Biểu đồ dung lượng bảng băm và kích thước bằng chứng gửi qua mạng.</a:t>
-            </a:r>
-            <a:br/>
-            <a:r>
-              <a:t>4. Biểu đồ kiểm tra khả năng mở rộng quy mô từ 50 tệp lên 1.000 tệp tin.</a:t>
+              <a:t>3. Nhấp Xóa lén tệp tin để mô phỏng hành vi xóa dữ liệu phá hoại.</a:t>
             </a:r>
           </a:p>
           <a:p>
@@ -7861,7 +8375,7 @@
               </a:defRPr>
             </a:pPr>
             <a:r>
-              <a:t>• Đo lường thời gian thực:</a:t>
+              <a:t>• Bước 3: Kiểm tra và định vị lỗi tức thì:</a:t>
             </a:r>
           </a:p>
           <a:p>
@@ -7876,7 +8390,7 @@
               </a:defRPr>
             </a:pPr>
             <a:r>
-              <a:t>Khi nhấp Đo lường và cập nhật lại biểu đồ ngay, hệ thống sẽ chạy đo đạc trực tiếp trên máy và vẽ kết quả tức thì.</a:t>
+              <a:t>Nhấp Chạy kiểm tra toàn vẹn. Hệ thống lập tức chỉ đúng tên tệp bị can thiệp, hiển thị tỷ lệ nguyên vẹn và tốc độ xử lý hơn 4.000 tệp mỗi giây.</a:t>
             </a:r>
           </a:p>
         </p:txBody>
@@ -7974,7 +8488,7 @@
               </a:defRPr>
             </a:pPr>
             <a:r>
-              <a:t>Ảnh Chụp Bảng Điều Khiển Biểu Đồ Benchmark Động</a:t>
+              <a:t>Ảnh Chụp Giao Diện Phòng Thí Nghiệm Web Demo</a:t>
             </a:r>
           </a:p>
           <a:p>
@@ -8001,7 +8515,7 @@
               </a:defRPr>
             </a:pPr>
             <a:r>
-              <a:t>• Chèn ảnh chụp màn hình Tab Benchmark Dashboard trên giao diện Web Demo.</a:t>
+              <a:t>• Chèn ảnh chụp màn hình phòng thí nghiệm Web Demo thực tế tại http://127.0.0.1:8080.</a:t>
             </a:r>
           </a:p>
           <a:p>
@@ -8016,7 +8530,7 @@
               </a:defRPr>
             </a:pPr>
             <a:r>
-              <a:t>• Thể hiện 4 biểu đồ Chart.js trực quan hóa kết quả đo đạc thực tế trên 1.000 tệp tin.</a:t>
+              <a:t>• Thể hiện 4 thẻ tab chuyển đổi mô hình (Flat SHA, HMAC, Merkle chuẩn, HD-Merkle).</a:t>
             </a:r>
           </a:p>
           <a:p>
@@ -8031,7 +8545,7 @@
               </a:defRPr>
             </a:pPr>
             <a:r>
-              <a:t>• Thể hiện 4 thẻ chỉ số KPI tốc độ xử lý và dung lượng bằng chứng ở đầu trang.</a:t>
+              <a:t>• Thể hiện 3 nút mô phỏng tấn công màu cam (Đảo bit, Bơm tệp, Xóa tệp).</a:t>
             </a:r>
           </a:p>
           <a:p>
@@ -8046,7 +8560,7 @@
               </a:defRPr>
             </a:pPr>
             <a:r>
-              <a:t>• Minh chứng khả năng đo lường và vẽ biểu đồ động thời gian thực hoàn toàn ngoại tuyến.</a:t>
+              <a:t>• Hiển thị bảng danh sách 1.000 tệp tin và thanh trạng thái tiến trình thời gian thực.</a:t>
             </a:r>
           </a:p>
         </p:txBody>
@@ -8224,7 +8738,537 @@
               </a:defRPr>
             </a:pPr>
             <a:r>
-              <a:t>16. Tổng Kết Đóng Góp Khoa Học Và Giá Trị Thực Tiễn Của Đồ Án</a:t>
+              <a:t>16. Bảng Điều Khiển Biểu Đồ Đo Đạc Trực Quan Hóa Động</a:t>
+            </a:r>
+          </a:p>
+        </p:txBody>
+      </p:sp>
+      <p:sp>
+        <p:nvSpPr>
+          <p:cNvPr id="6" name="Rounded Rectangle 5"/>
+          <p:cNvSpPr/>
+          <p:nvPr/>
+        </p:nvSpPr>
+        <p:spPr>
+          <a:xfrm>
+            <a:off x="731520" y="1234440"/>
+            <a:ext cx="5120640" cy="5257800"/>
+          </a:xfrm>
+          <a:prstGeom prst="roundRect">
+            <a:avLst/>
+          </a:prstGeom>
+          <a:solidFill>
+            <a:srgbClr val="FFFFFF"/>
+          </a:solidFill>
+          <a:ln w="15240">
+            <a:solidFill>
+              <a:srgbClr val="E2E8F0"/>
+            </a:solidFill>
+          </a:ln>
+        </p:spPr>
+        <p:style>
+          <a:lnRef idx="1">
+            <a:schemeClr val="accent1"/>
+          </a:lnRef>
+          <a:fillRef idx="3">
+            <a:schemeClr val="accent1"/>
+          </a:fillRef>
+          <a:effectRef idx="2">
+            <a:schemeClr val="accent1"/>
+          </a:effectRef>
+          <a:fontRef idx="minor">
+            <a:schemeClr val="lt1"/>
+          </a:fontRef>
+        </p:style>
+        <p:txBody>
+          <a:bodyPr rtlCol="0" anchor="ctr"/>
+          <a:lstStyle/>
+          <a:p>
+            <a:pPr algn="ctr"/>
+          </a:p>
+        </p:txBody>
+      </p:sp>
+      <p:sp>
+        <p:nvSpPr>
+          <p:cNvPr id="7" name="TextBox 6"/>
+          <p:cNvSpPr txBox="1"/>
+          <p:nvPr/>
+        </p:nvSpPr>
+        <p:spPr>
+          <a:xfrm>
+            <a:off x="960120" y="1399032"/>
+            <a:ext cx="4663440" cy="4965192"/>
+          </a:xfrm>
+          <a:prstGeom prst="rect">
+            <a:avLst/>
+          </a:prstGeom>
+          <a:noFill/>
+        </p:spPr>
+        <p:txBody>
+          <a:bodyPr wrap="square">
+            <a:spAutoFit/>
+          </a:bodyPr>
+          <a:lstStyle/>
+          <a:p>
+            <a:pPr>
+              <a:defRPr b="1" sz="1250">
+                <a:solidFill>
+                  <a:srgbClr val="1E3A8A"/>
+                </a:solidFill>
+              </a:defRPr>
+            </a:pPr>
+            <a:r>
+              <a:t>Trực Quan Hóa Biểu Đồ Khoa Học Hoạt Động Ngoại Tuyến</a:t>
+            </a:r>
+          </a:p>
+          <a:p>
+            <a:pPr>
+              <a:spcBef>
+                <a:spcPts val="500"/>
+              </a:spcBef>
+              <a:defRPr b="1" sz="1030">
+                <a:solidFill>
+                  <a:srgbClr val="2563EB"/>
+                </a:solidFill>
+              </a:defRPr>
+            </a:pPr>
+            <a:r>
+              <a:t>• Hoạt động hoàn toàn ngoại tuyến:</a:t>
+            </a:r>
+          </a:p>
+          <a:p>
+            <a:pPr>
+              <a:spcBef>
+                <a:spcPts val="150"/>
+              </a:spcBef>
+              <a:defRPr sz="950">
+                <a:solidFill>
+                  <a:srgbClr val="0F172A"/>
+                </a:solidFill>
+              </a:defRPr>
+            </a:pPr>
+            <a:r>
+              <a:t>Hệ thống tích hợp sẵn thư viện vẽ biểu đồ nội bộ, không cần kết nối mạng Internet vẫn hiển thị mượt mà và trực quan khi báo cáo trước hội đồng.</a:t>
+            </a:r>
+          </a:p>
+          <a:p>
+            <a:pPr>
+              <a:spcBef>
+                <a:spcPts val="500"/>
+              </a:spcBef>
+              <a:defRPr b="1" sz="1030">
+                <a:solidFill>
+                  <a:srgbClr val="2563EB"/>
+                </a:solidFill>
+              </a:defRPr>
+            </a:pPr>
+            <a:r>
+              <a:t>• 4 Biểu đồ phân tích khoa học chuyên sâu:</a:t>
+            </a:r>
+          </a:p>
+          <a:p>
+            <a:pPr>
+              <a:spcBef>
+                <a:spcPts val="150"/>
+              </a:spcBef>
+              <a:defRPr sz="950">
+                <a:solidFill>
+                  <a:srgbClr val="0F172A"/>
+                </a:solidFill>
+              </a:defRPr>
+            </a:pPr>
+            <a:r>
+              <a:t>1. Biểu đồ so sánh thời gian khởi tạo và xác minh của 4 mô hình trên 1.000 tệp tin.</a:t>
+            </a:r>
+            <a:br/>
+            <a:r>
+              <a:t>2. Biểu đồ chi phí cập nhật khi sửa 1 tệp tin phản hồi tức thì theo chiều cao cây.</a:t>
+            </a:r>
+            <a:br/>
+            <a:r>
+              <a:t>3. Biểu đồ dung lượng bảng băm và kích thước bằng chứng gửi qua mạng.</a:t>
+            </a:r>
+            <a:br/>
+            <a:r>
+              <a:t>4. Biểu đồ kiểm tra khả năng mở rộng quy mô từ 50 tệp lên 1.000 tệp tin.</a:t>
+            </a:r>
+          </a:p>
+          <a:p>
+            <a:pPr>
+              <a:spcBef>
+                <a:spcPts val="500"/>
+              </a:spcBef>
+              <a:defRPr b="1" sz="1030">
+                <a:solidFill>
+                  <a:srgbClr val="2563EB"/>
+                </a:solidFill>
+              </a:defRPr>
+            </a:pPr>
+            <a:r>
+              <a:t>• Đo lường thời gian thực:</a:t>
+            </a:r>
+          </a:p>
+          <a:p>
+            <a:pPr>
+              <a:spcBef>
+                <a:spcPts val="150"/>
+              </a:spcBef>
+              <a:defRPr sz="950">
+                <a:solidFill>
+                  <a:srgbClr val="0F172A"/>
+                </a:solidFill>
+              </a:defRPr>
+            </a:pPr>
+            <a:r>
+              <a:t>Khi nhấp Đo lường và cập nhật lại biểu đồ ngay, hệ thống sẽ chạy đo đạc trực tiếp trên máy và vẽ kết quả tức thì.</a:t>
+            </a:r>
+          </a:p>
+        </p:txBody>
+      </p:sp>
+      <p:sp>
+        <p:nvSpPr>
+          <p:cNvPr id="8" name="Rounded Rectangle 7"/>
+          <p:cNvSpPr/>
+          <p:nvPr/>
+        </p:nvSpPr>
+        <p:spPr>
+          <a:xfrm>
+            <a:off x="6035040" y="1234440"/>
+            <a:ext cx="5394960" cy="5257800"/>
+          </a:xfrm>
+          <a:prstGeom prst="roundRect">
+            <a:avLst/>
+          </a:prstGeom>
+          <a:solidFill>
+            <a:srgbClr val="F1F5F9"/>
+          </a:solidFill>
+          <a:ln w="19050">
+            <a:solidFill>
+              <a:srgbClr val="94A3B8"/>
+            </a:solidFill>
+          </a:ln>
+        </p:spPr>
+        <p:style>
+          <a:lnRef idx="1">
+            <a:schemeClr val="accent1"/>
+          </a:lnRef>
+          <a:fillRef idx="3">
+            <a:schemeClr val="accent1"/>
+          </a:fillRef>
+          <a:effectRef idx="2">
+            <a:schemeClr val="accent1"/>
+          </a:effectRef>
+          <a:fontRef idx="minor">
+            <a:schemeClr val="lt1"/>
+          </a:fontRef>
+        </p:style>
+        <p:txBody>
+          <a:bodyPr rtlCol="0" anchor="ctr"/>
+          <a:lstStyle/>
+          <a:p>
+            <a:pPr algn="ctr"/>
+          </a:p>
+        </p:txBody>
+      </p:sp>
+      <p:sp>
+        <p:nvSpPr>
+          <p:cNvPr id="9" name="TextBox 8"/>
+          <p:cNvSpPr txBox="1"/>
+          <p:nvPr/>
+        </p:nvSpPr>
+        <p:spPr>
+          <a:xfrm>
+            <a:off x="6263640" y="1463040"/>
+            <a:ext cx="4937760" cy="4800600"/>
+          </a:xfrm>
+          <a:prstGeom prst="rect">
+            <a:avLst/>
+          </a:prstGeom>
+          <a:noFill/>
+        </p:spPr>
+        <p:txBody>
+          <a:bodyPr wrap="square">
+            <a:spAutoFit/>
+          </a:bodyPr>
+          <a:lstStyle/>
+          <a:p>
+            <a:pPr>
+              <a:defRPr b="1" sz="1000">
+                <a:solidFill>
+                  <a:srgbClr val="2563EB"/>
+                </a:solidFill>
+              </a:defRPr>
+            </a:pPr>
+            <a:r>
+              <a:t>[ VỊ TRÍ CHÈN SƠ ĐỒ / ẢNH DRAW.IO ]</a:t>
+            </a:r>
+          </a:p>
+          <a:p>
+            <a:pPr>
+              <a:spcBef>
+                <a:spcPts val="400"/>
+              </a:spcBef>
+              <a:spcAft>
+                <a:spcPts val="800"/>
+              </a:spcAft>
+              <a:defRPr b="1" sz="1250">
+                <a:solidFill>
+                  <a:srgbClr val="1E3A8A"/>
+                </a:solidFill>
+              </a:defRPr>
+            </a:pPr>
+            <a:r>
+              <a:t>Ảnh Chụp Bảng Điều Khiển Biểu Đồ Benchmark Động</a:t>
+            </a:r>
+          </a:p>
+          <a:p>
+            <a:pPr>
+              <a:defRPr b="1" sz="950">
+                <a:solidFill>
+                  <a:srgbClr val="64748B"/>
+                </a:solidFill>
+              </a:defRPr>
+            </a:pPr>
+            <a:r>
+              <a:t>Gợi ý các thành phần cần thiết kế trên Draw.io hoặc chèn ảnh:</a:t>
+            </a:r>
+          </a:p>
+          <a:p>
+            <a:pPr>
+              <a:spcBef>
+                <a:spcPts val="300"/>
+              </a:spcBef>
+              <a:defRPr sz="880">
+                <a:solidFill>
+                  <a:srgbClr val="0F172A"/>
+                </a:solidFill>
+              </a:defRPr>
+            </a:pPr>
+            <a:r>
+              <a:t>• Chèn ảnh chụp màn hình Tab Benchmark Dashboard trên giao diện Web Demo.</a:t>
+            </a:r>
+          </a:p>
+          <a:p>
+            <a:pPr>
+              <a:spcBef>
+                <a:spcPts val="300"/>
+              </a:spcBef>
+              <a:defRPr sz="880">
+                <a:solidFill>
+                  <a:srgbClr val="0F172A"/>
+                </a:solidFill>
+              </a:defRPr>
+            </a:pPr>
+            <a:r>
+              <a:t>• Thể hiện 4 biểu đồ Chart.js trực quan hóa kết quả đo đạc thực tế trên 1.000 tệp tin.</a:t>
+            </a:r>
+          </a:p>
+          <a:p>
+            <a:pPr>
+              <a:spcBef>
+                <a:spcPts val="300"/>
+              </a:spcBef>
+              <a:defRPr sz="880">
+                <a:solidFill>
+                  <a:srgbClr val="0F172A"/>
+                </a:solidFill>
+              </a:defRPr>
+            </a:pPr>
+            <a:r>
+              <a:t>• Thể hiện 4 thẻ chỉ số KPI tốc độ xử lý và dung lượng bằng chứng ở đầu trang.</a:t>
+            </a:r>
+          </a:p>
+          <a:p>
+            <a:pPr>
+              <a:spcBef>
+                <a:spcPts val="300"/>
+              </a:spcBef>
+              <a:defRPr sz="880">
+                <a:solidFill>
+                  <a:srgbClr val="0F172A"/>
+                </a:solidFill>
+              </a:defRPr>
+            </a:pPr>
+            <a:r>
+              <a:t>• Minh chứng khả năng đo lường và vẽ biểu đồ động thời gian thực hoàn toàn ngoại tuyến.</a:t>
+            </a:r>
+          </a:p>
+        </p:txBody>
+      </p:sp>
+    </p:spTree>
+  </p:cSld>
+  <p:clrMapOvr>
+    <a:masterClrMapping/>
+  </p:clrMapOvr>
+</p:sld>
+</file>
+
+<file path=ppt/slides/slide18.xml><?xml version="1.0" encoding="utf-8"?>
+<p:sld xmlns:a="http://schemas.openxmlformats.org/drawingml/2006/main" xmlns:p="http://schemas.openxmlformats.org/presentationml/2006/main" xmlns:r="http://schemas.openxmlformats.org/officeDocument/2006/relationships">
+  <p:cSld>
+    <p:spTree>
+      <p:nvGrpSpPr>
+        <p:cNvPr id="1" name=""/>
+        <p:cNvGrpSpPr/>
+        <p:nvPr/>
+      </p:nvGrpSpPr>
+      <p:grpSpPr/>
+      <p:sp>
+        <p:nvSpPr>
+          <p:cNvPr id="2" name="Rectangle 1"/>
+          <p:cNvSpPr/>
+          <p:nvPr/>
+        </p:nvSpPr>
+        <p:spPr>
+          <a:xfrm>
+            <a:off x="0" y="0"/>
+            <a:ext cx="12191695" cy="6858000"/>
+          </a:xfrm>
+          <a:prstGeom prst="rect">
+            <a:avLst/>
+          </a:prstGeom>
+          <a:solidFill>
+            <a:srgbClr val="F8FAFC"/>
+          </a:solidFill>
+          <a:ln>
+            <a:solidFill>
+              <a:srgbClr val="F8FAFC"/>
+            </a:solidFill>
+          </a:ln>
+        </p:spPr>
+        <p:style>
+          <a:lnRef idx="1">
+            <a:schemeClr val="accent1"/>
+          </a:lnRef>
+          <a:fillRef idx="3">
+            <a:schemeClr val="accent1"/>
+          </a:fillRef>
+          <a:effectRef idx="2">
+            <a:schemeClr val="accent1"/>
+          </a:effectRef>
+          <a:fontRef idx="minor">
+            <a:schemeClr val="lt1"/>
+          </a:fontRef>
+        </p:style>
+        <p:txBody>
+          <a:bodyPr rtlCol="0" anchor="ctr"/>
+          <a:lstStyle/>
+          <a:p>
+            <a:pPr algn="ctr"/>
+          </a:p>
+        </p:txBody>
+      </p:sp>
+      <p:sp>
+        <p:nvSpPr>
+          <p:cNvPr id="3" name="Rectangle 2"/>
+          <p:cNvSpPr/>
+          <p:nvPr/>
+        </p:nvSpPr>
+        <p:spPr>
+          <a:xfrm>
+            <a:off x="0" y="0"/>
+            <a:ext cx="12191695" cy="1051560"/>
+          </a:xfrm>
+          <a:prstGeom prst="rect">
+            <a:avLst/>
+          </a:prstGeom>
+          <a:solidFill>
+            <a:srgbClr val="1E3A8A"/>
+          </a:solidFill>
+          <a:ln>
+            <a:solidFill>
+              <a:srgbClr val="1E3A8A"/>
+            </a:solidFill>
+          </a:ln>
+        </p:spPr>
+        <p:style>
+          <a:lnRef idx="1">
+            <a:schemeClr val="accent1"/>
+          </a:lnRef>
+          <a:fillRef idx="3">
+            <a:schemeClr val="accent1"/>
+          </a:fillRef>
+          <a:effectRef idx="2">
+            <a:schemeClr val="accent1"/>
+          </a:effectRef>
+          <a:fontRef idx="minor">
+            <a:schemeClr val="lt1"/>
+          </a:fontRef>
+        </p:style>
+        <p:txBody>
+          <a:bodyPr rtlCol="0" anchor="ctr"/>
+          <a:lstStyle/>
+          <a:p>
+            <a:pPr algn="ctr"/>
+          </a:p>
+        </p:txBody>
+      </p:sp>
+      <p:sp>
+        <p:nvSpPr>
+          <p:cNvPr id="4" name="TextBox 3"/>
+          <p:cNvSpPr txBox="1"/>
+          <p:nvPr/>
+        </p:nvSpPr>
+        <p:spPr>
+          <a:xfrm>
+            <a:off x="731520" y="109728"/>
+            <a:ext cx="10698480" cy="274320"/>
+          </a:xfrm>
+          <a:prstGeom prst="rect">
+            <a:avLst/>
+          </a:prstGeom>
+          <a:noFill/>
+        </p:spPr>
+        <p:txBody>
+          <a:bodyPr wrap="square">
+            <a:spAutoFit/>
+          </a:bodyPr>
+          <a:lstStyle/>
+          <a:p>
+            <a:pPr>
+              <a:defRPr sz="1100" b="1">
+                <a:solidFill>
+                  <a:srgbClr val="93C5FD"/>
+                </a:solidFill>
+              </a:defRPr>
+            </a:pPr>
+            <a:r>
+              <a:t>PHẦN 5: TRÌNH DIỄN THỰC TẾ VÀ TỔNG KẾT</a:t>
+            </a:r>
+          </a:p>
+        </p:txBody>
+      </p:sp>
+      <p:sp>
+        <p:nvSpPr>
+          <p:cNvPr id="5" name="TextBox 4"/>
+          <p:cNvSpPr txBox="1"/>
+          <p:nvPr/>
+        </p:nvSpPr>
+        <p:spPr>
+          <a:xfrm>
+            <a:off x="731520" y="384048"/>
+            <a:ext cx="10698480" cy="548640"/>
+          </a:xfrm>
+          <a:prstGeom prst="rect">
+            <a:avLst/>
+          </a:prstGeom>
+          <a:noFill/>
+        </p:spPr>
+        <p:txBody>
+          <a:bodyPr wrap="square">
+            <a:spAutoFit/>
+          </a:bodyPr>
+          <a:lstStyle/>
+          <a:p>
+            <a:pPr>
+              <a:defRPr sz="1750" b="1">
+                <a:solidFill>
+                  <a:srgbClr val="FFFFFF"/>
+                </a:solidFill>
+              </a:defRPr>
+            </a:pPr>
+            <a:r>
+              <a:t>17. Tổng Kết Đóng Góp Khoa Học Và Giá Trị Thực Tiễn Của Đồ Án</a:t>
             </a:r>
           </a:p>
         </p:txBody>

</xml_diff>

<commit_message>
feat(slide2): replace right academic card with authentic Oxford Academic web article screenshot
</commit_message>
<xml_diff>
--- a/docs/Bao_Cao_Giua_Ky_DT05.pptx
+++ b/docs/Bao_Cao_Giua_Ky_DT05.pptx
@@ -10770,80 +10770,14 @@
       </p:sp>
       <p:sp>
         <p:nvSpPr>
-          <p:cNvPr id="9" name="Rounded Rectangle 8"/>
-          <p:cNvSpPr/>
-          <p:nvPr/>
-        </p:nvSpPr>
-        <p:spPr>
-          <a:xfrm>
-            <a:off x="6263640" y="1417320"/>
-            <a:ext cx="4937760" cy="594360"/>
-          </a:xfrm>
-          <a:prstGeom prst="roundRect">
-            <a:avLst/>
-          </a:prstGeom>
-          <a:solidFill>
-            <a:srgbClr val="1E3A8A"/>
-          </a:solidFill>
-          <a:ln>
-            <a:solidFill>
-              <a:srgbClr val="1E3A8A"/>
-            </a:solidFill>
-          </a:ln>
-        </p:spPr>
-        <p:style>
-          <a:lnRef idx="1">
-            <a:schemeClr val="accent1"/>
-          </a:lnRef>
-          <a:fillRef idx="3">
-            <a:schemeClr val="accent1"/>
-          </a:fillRef>
-          <a:effectRef idx="2">
-            <a:schemeClr val="accent1"/>
-          </a:effectRef>
-          <a:fontRef idx="minor">
-            <a:schemeClr val="lt1"/>
-          </a:fontRef>
-        </p:style>
-        <p:txBody>
-          <a:bodyPr rtlCol="0" anchor="ctr" wrap="square"/>
-          <a:lstStyle/>
-          <a:p>
-            <a:pPr algn="ctr">
-              <a:defRPr b="1" sz="1000">
-                <a:solidFill>
-                  <a:srgbClr val="FFFFFF"/>
-                </a:solidFill>
-              </a:defRPr>
-            </a:pPr>
-            <a:r>
-              <a:t>OXFORD JOURNAL OF CYBERSECURITY (OXFORD UNIVERSITY PRESS)</a:t>
-            </a:r>
-          </a:p>
-          <a:p>
-            <a:pPr>
-              <a:defRPr sz="900">
-                <a:solidFill>
-                  <a:srgbClr val="FFFFFF"/>
-                </a:solidFill>
-              </a:defRPr>
-            </a:pPr>
-            <a:r>
-              <a:t>ISSN 2057-2085 • Tập 11, Số 1, Năm 2025 • Article ID: tyae024</a:t>
-            </a:r>
-          </a:p>
-        </p:txBody>
-      </p:sp>
-      <p:sp>
-        <p:nvSpPr>
-          <p:cNvPr id="10" name="TextBox 9"/>
+          <p:cNvPr id="9" name="TextBox 8"/>
           <p:cNvSpPr txBox="1"/>
           <p:nvPr/>
         </p:nvSpPr>
         <p:spPr>
           <a:xfrm>
-            <a:off x="6263640" y="2148840"/>
-            <a:ext cx="4937760" cy="4206240"/>
+            <a:off x="6217920" y="1344168"/>
+            <a:ext cx="5029200" cy="411480"/>
           </a:xfrm>
           <a:prstGeom prst="rect">
             <a:avLst/>
@@ -10857,33 +10791,54 @@
           <a:lstStyle/>
           <a:p>
             <a:pPr>
-              <a:defRPr b="1" sz="1350">
+              <a:defRPr b="1" sz="1100">
                 <a:solidFill>
                   <a:srgbClr val="1E3A8A"/>
                 </a:solidFill>
               </a:defRPr>
             </a:pPr>
             <a:r>
-              <a:t>The Adversary: The Philosophy of Cryptography</a:t>
-            </a:r>
-          </a:p>
-          <a:p>
-            <a:pPr>
-              <a:spcAft>
-                <a:spcPts val="800"/>
-              </a:spcAft>
-              <a:defRPr sz="1000">
-                <a:solidFill>
-                  <a:srgbClr val="2563EB"/>
-                </a:solidFill>
-              </a:defRPr>
-            </a:pPr>
-            <a:r>
-              <a:t>Tác giả: Harry Halpin  |  Đơn vị: Nym Technologies &amp; Inria Research</a:t>
-            </a:r>
-          </a:p>
-        </p:txBody>
-      </p:sp>
+              <a:t>ẢNH CHỤP BÀI BÁO THỰC TẾ TRÊN CỔNG OXFORD ACADEMIC</a:t>
+            </a:r>
+          </a:p>
+          <a:p>
+            <a:pPr>
+              <a:defRPr sz="819">
+                <a:solidFill>
+                  <a:srgbClr val="64748B"/>
+                </a:solidFill>
+              </a:defRPr>
+            </a:pPr>
+            <a:r>
+              <a:t>Cổng xuất bản: academic.oup.com/cybersecurity  |  DOI: 10.1093/cybsec/tyaf006</a:t>
+            </a:r>
+          </a:p>
+        </p:txBody>
+      </p:sp>
+      <p:pic>
+        <p:nvPicPr>
+          <p:cNvPr id="10" name="Picture 9" descr="paper_web_article_clean.png"/>
+          <p:cNvPicPr>
+            <a:picLocks noChangeAspect="1"/>
+          </p:cNvPicPr>
+          <p:nvPr/>
+        </p:nvPicPr>
+        <p:blipFill>
+          <a:blip r:embed="rId2"/>
+          <a:stretch>
+            <a:fillRect/>
+          </a:stretch>
+        </p:blipFill>
+        <p:spPr>
+          <a:xfrm>
+            <a:off x="6217920" y="1783080"/>
+            <a:ext cx="5029200" cy="3709319"/>
+          </a:xfrm>
+          <a:prstGeom prst="rect">
+            <a:avLst/>
+          </a:prstGeom>
+        </p:spPr>
+      </p:pic>
       <p:sp>
         <p:nvSpPr>
           <p:cNvPr id="11" name="Rounded Rectangle 10"/>
@@ -10892,8 +10847,8 @@
         </p:nvSpPr>
         <p:spPr>
           <a:xfrm>
-            <a:off x="6263640" y="3017520"/>
-            <a:ext cx="4937760" cy="1691640"/>
+            <a:off x="6217920" y="5577840"/>
+            <a:ext cx="5029200" cy="777240"/>
           </a:xfrm>
           <a:prstGeom prst="roundRect">
             <a:avLst/>
@@ -10901,7 +10856,7 @@
           <a:solidFill>
             <a:srgbClr val="EFF6FF"/>
           </a:solidFill>
-          <a:ln>
+          <a:ln w="12700">
             <a:solidFill>
               <a:srgbClr val="2563EB"/>
             </a:solidFill>
@@ -10926,245 +10881,33 @@
           <a:lstStyle/>
           <a:p>
             <a:pPr algn="ctr">
-              <a:defRPr b="1" sz="950">
+              <a:defRPr b="1" sz="900">
                 <a:solidFill>
                   <a:srgbClr val="1E3A8A"/>
                 </a:solidFill>
               </a:defRPr>
             </a:pPr>
             <a:r>
-              <a:t>[ TRÍCH ĐOẠN LUẬN ĐIỂM CỐT LÕI TỪ BÀI BÁO ]</a:t>
-            </a:r>
-          </a:p>
-          <a:p>
-            <a:pPr>
-              <a:spcBef>
-                <a:spcPts val="400"/>
-              </a:spcBef>
-              <a:defRPr sz="900">
+              <a:t>XÁC NHẬN MINH CHỨNG XUẤT BẢN KHOA HỌC CHÍNH THỨC</a:t>
+            </a:r>
+          </a:p>
+          <a:p>
+            <a:pPr>
+              <a:spcBef>
+                <a:spcPts val="200"/>
+              </a:spcBef>
+              <a:defRPr sz="819">
                 <a:solidFill>
                   <a:srgbClr val="0F172A"/>
                 </a:solidFill>
               </a:defRPr>
             </a:pPr>
             <a:r>
-              <a:t>“Mật mã học không chỉ là bài toán mã hóa dữ liệu tĩnh, mà là sự tương tác đối kháng hình thức giữa người xây dựng hệ thống và Kẻ thù (The Adversary). Để bảo đảm toàn vẹn kho dữ liệu, bắt buộc phải sử dụng cây Merkle phân tách miền (RFC 6962) và kiểm nghiệm trên dữ liệu thực tế biến thiên.”</a:t>
-            </a:r>
-          </a:p>
-        </p:txBody>
-      </p:sp>
-      <p:sp>
-        <p:nvSpPr>
-          <p:cNvPr id="12" name="Rounded Rectangle 11"/>
-          <p:cNvSpPr/>
-          <p:nvPr/>
-        </p:nvSpPr>
-        <p:spPr>
-          <a:xfrm>
-            <a:off x="6263640" y="4892040"/>
-            <a:ext cx="2423160" cy="566928"/>
-          </a:xfrm>
-          <a:prstGeom prst="roundRect">
-            <a:avLst/>
-          </a:prstGeom>
-          <a:solidFill>
-            <a:srgbClr val="EFF6FF"/>
-          </a:solidFill>
-          <a:ln>
-            <a:solidFill>
-              <a:srgbClr val="2563EB"/>
-            </a:solidFill>
-          </a:ln>
-        </p:spPr>
-        <p:style>
-          <a:lnRef idx="1">
-            <a:schemeClr val="accent1"/>
-          </a:lnRef>
-          <a:fillRef idx="3">
-            <a:schemeClr val="accent1"/>
-          </a:fillRef>
-          <a:effectRef idx="2">
-            <a:schemeClr val="accent1"/>
-          </a:effectRef>
-          <a:fontRef idx="minor">
-            <a:schemeClr val="lt1"/>
-          </a:fontRef>
-        </p:style>
-        <p:txBody>
-          <a:bodyPr rtlCol="0" anchor="ctr" wrap="square"/>
-          <a:lstStyle/>
-          <a:p>
-            <a:pPr algn="ctr">
-              <a:defRPr b="1" sz="880">
-                <a:solidFill>
-                  <a:srgbClr val="2563EB"/>
-                </a:solidFill>
-              </a:defRPr>
-            </a:pPr>
-            <a:r>
-              <a:t>✓ Kẻ thù PPT &amp; Dolev-Yao</a:t>
-            </a:r>
-          </a:p>
-        </p:txBody>
-      </p:sp>
-      <p:sp>
-        <p:nvSpPr>
-          <p:cNvPr id="13" name="Rounded Rectangle 12"/>
-          <p:cNvSpPr/>
-          <p:nvPr/>
-        </p:nvSpPr>
-        <p:spPr>
-          <a:xfrm>
-            <a:off x="8778240" y="4892040"/>
-            <a:ext cx="2423160" cy="566928"/>
-          </a:xfrm>
-          <a:prstGeom prst="roundRect">
-            <a:avLst/>
-          </a:prstGeom>
-          <a:solidFill>
-            <a:srgbClr val="ECFDF5"/>
-          </a:solidFill>
-          <a:ln>
-            <a:solidFill>
-              <a:srgbClr val="059669"/>
-            </a:solidFill>
-          </a:ln>
-        </p:spPr>
-        <p:style>
-          <a:lnRef idx="1">
-            <a:schemeClr val="accent1"/>
-          </a:lnRef>
-          <a:fillRef idx="3">
-            <a:schemeClr val="accent1"/>
-          </a:fillRef>
-          <a:effectRef idx="2">
-            <a:schemeClr val="accent1"/>
-          </a:effectRef>
-          <a:fontRef idx="minor">
-            <a:schemeClr val="lt1"/>
-          </a:fontRef>
-        </p:style>
-        <p:txBody>
-          <a:bodyPr rtlCol="0" anchor="ctr" wrap="square"/>
-          <a:lstStyle/>
-          <a:p>
-            <a:pPr algn="ctr">
-              <a:defRPr b="1" sz="880">
-                <a:solidFill>
-                  <a:srgbClr val="059669"/>
-                </a:solidFill>
-              </a:defRPr>
-            </a:pPr>
-            <a:r>
-              <a:t>✓ Chuẩn RFC 6962 Domain Separation</a:t>
-            </a:r>
-          </a:p>
-        </p:txBody>
-      </p:sp>
-      <p:sp>
-        <p:nvSpPr>
-          <p:cNvPr id="14" name="Rounded Rectangle 13"/>
-          <p:cNvSpPr/>
-          <p:nvPr/>
-        </p:nvSpPr>
-        <p:spPr>
-          <a:xfrm>
-            <a:off x="6263640" y="5577840"/>
-            <a:ext cx="2423160" cy="566928"/>
-          </a:xfrm>
-          <a:prstGeom prst="roundRect">
-            <a:avLst/>
-          </a:prstGeom>
-          <a:solidFill>
-            <a:srgbClr val="FAF5FF"/>
-          </a:solidFill>
-          <a:ln>
-            <a:solidFill>
-              <a:srgbClr val="7E22CE"/>
-            </a:solidFill>
-          </a:ln>
-        </p:spPr>
-        <p:style>
-          <a:lnRef idx="1">
-            <a:schemeClr val="accent1"/>
-          </a:lnRef>
-          <a:fillRef idx="3">
-            <a:schemeClr val="accent1"/>
-          </a:fillRef>
-          <a:effectRef idx="2">
-            <a:schemeClr val="accent1"/>
-          </a:effectRef>
-          <a:fontRef idx="minor">
-            <a:schemeClr val="lt1"/>
-          </a:fontRef>
-        </p:style>
-        <p:txBody>
-          <a:bodyPr rtlCol="0" anchor="ctr" wrap="square"/>
-          <a:lstStyle/>
-          <a:p>
-            <a:pPr algn="ctr">
-              <a:defRPr b="1" sz="880">
-                <a:solidFill>
-                  <a:srgbClr val="7E22CE"/>
-                </a:solidFill>
-              </a:defRPr>
-            </a:pPr>
-            <a:r>
-              <a:t>✓ Cây Merkle &amp; Xác minh O(log N)</a:t>
-            </a:r>
-          </a:p>
-        </p:txBody>
-      </p:sp>
-      <p:sp>
-        <p:nvSpPr>
-          <p:cNvPr id="15" name="Rounded Rectangle 14"/>
-          <p:cNvSpPr/>
-          <p:nvPr/>
-        </p:nvSpPr>
-        <p:spPr>
-          <a:xfrm>
-            <a:off x="8778240" y="5577840"/>
-            <a:ext cx="2423160" cy="566928"/>
-          </a:xfrm>
-          <a:prstGeom prst="roundRect">
-            <a:avLst/>
-          </a:prstGeom>
-          <a:solidFill>
-            <a:srgbClr val="FEF3C7"/>
-          </a:solidFill>
-          <a:ln>
-            <a:solidFill>
-              <a:srgbClr val="D97706"/>
-            </a:solidFill>
-          </a:ln>
-        </p:spPr>
-        <p:style>
-          <a:lnRef idx="1">
-            <a:schemeClr val="accent1"/>
-          </a:lnRef>
-          <a:fillRef idx="3">
-            <a:schemeClr val="accent1"/>
-          </a:fillRef>
-          <a:effectRef idx="2">
-            <a:schemeClr val="accent1"/>
-          </a:effectRef>
-          <a:fontRef idx="minor">
-            <a:schemeClr val="lt1"/>
-          </a:fontRef>
-        </p:style>
-        <p:txBody>
-          <a:bodyPr rtlCol="0" anchor="ctr" wrap="square"/>
-          <a:lstStyle/>
-          <a:p>
-            <a:pPr algn="ctr">
-              <a:defRPr b="1" sz="880">
-                <a:solidFill>
-                  <a:srgbClr val="D97706"/>
-                </a:solidFill>
-              </a:defRPr>
-            </a:pPr>
-            <a:r>
-              <a:t>✓ Nguyên lý Kerckhoffs &amp; Kênh kề</a:t>
+              <a:t>• Tạp chí: Oxford Journal of Cybersecurity (Oxford University Press)  |  Tập 11, Số 1, 2025</a:t>
+            </a:r>
+            <a:br/>
+            <a:r>
+              <a:t>• Tác giả: Harry Halpin (Nym Technologies &amp; Inria)  |  Đăng tải: 27/03/2025  |  ID: tyaf006</a:t>
             </a:r>
           </a:p>
         </p:txBody>

</xml_diff>

<commit_message>
fix(slide2,slide3): remove duplicate badge box on slide 2, remove parentheses and code filenames, update diagram to 3 baseline models architecture on slide 3
</commit_message>
<xml_diff>
--- a/docs/Bao_Cao_Giua_Ky_DT05.pptx
+++ b/docs/Bao_Cao_Giua_Ky_DT05.pptx
@@ -10776,8 +10776,8 @@
         </p:nvSpPr>
         <p:spPr>
           <a:xfrm>
-            <a:off x="6217920" y="1344168"/>
-            <a:ext cx="5029200" cy="411480"/>
+            <a:off x="6263640" y="1399032"/>
+            <a:ext cx="4937760" cy="502920"/>
           </a:xfrm>
           <a:prstGeom prst="rect">
             <a:avLst/>
@@ -10791,7 +10791,7 @@
           <a:lstStyle/>
           <a:p>
             <a:pPr>
-              <a:defRPr b="1" sz="1100">
+              <a:defRPr b="1" sz="1150">
                 <a:solidFill>
                   <a:srgbClr val="1E3A8A"/>
                 </a:solidFill>
@@ -10803,7 +10803,10 @@
           </a:p>
           <a:p>
             <a:pPr>
-              <a:defRPr sz="819">
+              <a:spcBef>
+                <a:spcPts val="200"/>
+              </a:spcBef>
+              <a:defRPr sz="850">
                 <a:solidFill>
                   <a:srgbClr val="64748B"/>
                 </a:solidFill>
@@ -10831,87 +10834,14 @@
         </p:blipFill>
         <p:spPr>
           <a:xfrm>
-            <a:off x="6217920" y="1783080"/>
-            <a:ext cx="5029200" cy="3709319"/>
+            <a:off x="6263640" y="2011680"/>
+            <a:ext cx="4937760" cy="3641877"/>
           </a:xfrm>
           <a:prstGeom prst="rect">
             <a:avLst/>
           </a:prstGeom>
         </p:spPr>
       </p:pic>
-      <p:sp>
-        <p:nvSpPr>
-          <p:cNvPr id="11" name="Rounded Rectangle 10"/>
-          <p:cNvSpPr/>
-          <p:nvPr/>
-        </p:nvSpPr>
-        <p:spPr>
-          <a:xfrm>
-            <a:off x="6217920" y="5577840"/>
-            <a:ext cx="5029200" cy="777240"/>
-          </a:xfrm>
-          <a:prstGeom prst="roundRect">
-            <a:avLst/>
-          </a:prstGeom>
-          <a:solidFill>
-            <a:srgbClr val="EFF6FF"/>
-          </a:solidFill>
-          <a:ln w="12700">
-            <a:solidFill>
-              <a:srgbClr val="2563EB"/>
-            </a:solidFill>
-          </a:ln>
-        </p:spPr>
-        <p:style>
-          <a:lnRef idx="1">
-            <a:schemeClr val="accent1"/>
-          </a:lnRef>
-          <a:fillRef idx="3">
-            <a:schemeClr val="accent1"/>
-          </a:fillRef>
-          <a:effectRef idx="2">
-            <a:schemeClr val="accent1"/>
-          </a:effectRef>
-          <a:fontRef idx="minor">
-            <a:schemeClr val="lt1"/>
-          </a:fontRef>
-        </p:style>
-        <p:txBody>
-          <a:bodyPr rtlCol="0" anchor="ctr" wrap="square"/>
-          <a:lstStyle/>
-          <a:p>
-            <a:pPr algn="ctr">
-              <a:defRPr b="1" sz="900">
-                <a:solidFill>
-                  <a:srgbClr val="1E3A8A"/>
-                </a:solidFill>
-              </a:defRPr>
-            </a:pPr>
-            <a:r>
-              <a:t>XÁC NHẬN MINH CHỨNG XUẤT BẢN KHOA HỌC CHÍNH THỨC</a:t>
-            </a:r>
-          </a:p>
-          <a:p>
-            <a:pPr>
-              <a:spcBef>
-                <a:spcPts val="200"/>
-              </a:spcBef>
-              <a:defRPr sz="819">
-                <a:solidFill>
-                  <a:srgbClr val="0F172A"/>
-                </a:solidFill>
-              </a:defRPr>
-            </a:pPr>
-            <a:r>
-              <a:t>• Tạp chí: Oxford Journal of Cybersecurity (Oxford University Press)  |  Tập 11, Số 1, 2025</a:t>
-            </a:r>
-            <a:br/>
-            <a:r>
-              <a:t>• Tác giả: Harry Halpin (Nym Technologies &amp; Inria)  |  Đăng tải: 27/03/2025  |  ID: tyaf006</a:t>
-            </a:r>
-          </a:p>
-        </p:txBody>
-      </p:sp>
     </p:spTree>
   </p:cSld>
   <p:clrMapOvr>
@@ -11183,7 +11113,7 @@
           <a:lstStyle/>
           <a:p>
             <a:pPr>
-              <a:defRPr b="1" sz="1200">
+              <a:defRPr b="1" sz="1250">
                 <a:solidFill>
                   <a:srgbClr val="1E3A8A"/>
                 </a:solidFill>
@@ -11198,14 +11128,14 @@
               <a:spcBef>
                 <a:spcPts val="450"/>
               </a:spcBef>
-              <a:defRPr b="1" sz="1000">
+              <a:defRPr b="1" sz="1050">
                 <a:solidFill>
                   <a:srgbClr val="2563EB"/>
                 </a:solidFill>
               </a:defRPr>
             </a:pPr>
             <a:r>
-              <a:t>• 1. Danh sách băm phẳng SHA-256 (sha256_manifest.py):</a:t>
+              <a:t>• 1. Danh sách băm phẳng SHA-256:</a:t>
             </a:r>
           </a:p>
           <a:p>
@@ -11213,14 +11143,14 @@
               <a:spcBef>
                 <a:spcPts val="150"/>
               </a:spcBef>
-              <a:defRPr sz="950">
+              <a:defRPr sz="1000">
                 <a:solidFill>
                   <a:srgbClr val="0F172A"/>
                 </a:solidFill>
               </a:defRPr>
             </a:pPr>
             <a:r>
-              <a:t>Băm tuần tự từng tệp tin; khởi tạo ~62.6 ms trên 1.000 tệp. Phát hiện 100% sai khác. Hạn chế: Client phải tải toàn bộ danh mục 111 KB để xác minh 1 tệp.</a:t>
+              <a:t>Băm tuần tự từng tệp tin dữ liệu, thời gian khởi tạo 62.6 ms trên 1.000 tệp. Phát hiện chính xác 100% mọi sai lệch dữ liệu. Hạn chế lớn là máy khách phải tải về toàn bộ danh mục 111 KB chỉ để xác minh 1 tệp tin duy nhất.</a:t>
             </a:r>
           </a:p>
           <a:p>
@@ -11228,14 +11158,14 @@
               <a:spcBef>
                 <a:spcPts val="450"/>
               </a:spcBef>
-              <a:defRPr b="1" sz="1000">
+              <a:defRPr b="1" sz="1050">
                 <a:solidFill>
                   <a:srgbClr val="2563EB"/>
                 </a:solidFill>
               </a:defRPr>
             </a:pPr>
             <a:r>
-              <a:t>• 2. Danh sách băm có khóa bí mật HMAC-SHA256 (hmac_manifest.py):</a:t>
+              <a:t>• 2. Danh sách băm có khóa bí mật HMAC-SHA256:</a:t>
             </a:r>
           </a:p>
           <a:p>
@@ -11243,14 +11173,14 @@
               <a:spcBef>
                 <a:spcPts val="150"/>
               </a:spcBef>
-              <a:defRPr sz="950">
+              <a:defRPr sz="1000">
                 <a:solidFill>
                   <a:srgbClr val="0F172A"/>
                 </a:solidFill>
               </a:defRPr>
             </a:pPr>
             <a:r>
-              <a:t>Sử dụng khóa đối xứng K chống giả mạo danh mục (~60.6 ms). Hạn chế: Buộc phải phân phối và quản lý khóa bí mật K cho mọi client.</a:t>
+              <a:t>Sử dụng khóa bí mật đối xứng để chống giả mạo danh mục băm, thời gian khởi tạo 60.6 ms. Hạn chế là bắt buộc phải phân phối và quản lý lưu trữ an toàn khóa bí mật cho tất cả các máy khách.</a:t>
             </a:r>
           </a:p>
           <a:p>
@@ -11258,14 +11188,14 @@
               <a:spcBef>
                 <a:spcPts val="450"/>
               </a:spcBef>
-              <a:defRPr b="1" sz="1000">
+              <a:defRPr b="1" sz="1050">
                 <a:solidFill>
                   <a:srgbClr val="2563EB"/>
                 </a:solidFill>
               </a:defRPr>
             </a:pPr>
             <a:r>
-              <a:t>• 3. Cây Merkle nhị phân truyền thống (standard_merkle_tree.py):</a:t>
+              <a:t>• 3. Cây Merkle nhị phân truyền thống:</a:t>
             </a:r>
           </a:p>
           <a:p>
@@ -11273,14 +11203,14 @@
               <a:spcBef>
                 <a:spcPts val="150"/>
               </a:spcBef>
-              <a:defRPr sz="950">
+              <a:defRPr sz="1000">
                 <a:solidFill>
                   <a:srgbClr val="0F172A"/>
                 </a:solidFill>
               </a:defRPr>
             </a:pPr>
             <a:r>
-              <a:t>Cây Merkle phẳng theo Ralph Merkle (1979); sinh Merkle Proof 990 Byte, xác minh trong 0.02 ms. Hạn chế: Bế tắc Rebuild O(N) khi sửa đổi tệp.</a:t>
+              <a:t>Dựng cấu trúc cây theo nguyên bản Merkle năm 1979, kích thước bằng chứng xác thực 990 Byte, thời gian xác minh siêu nhanh 0.02 ms. Hạn chế lớn là bế tắc khi phải dựng lại toàn bộ cây khi thêm, sửa hoặc xóa tệp tin.</a:t>
             </a:r>
           </a:p>
           <a:p>
@@ -11288,14 +11218,14 @@
               <a:spcBef>
                 <a:spcPts val="450"/>
               </a:spcBef>
-              <a:defRPr b="1" sz="1000">
+              <a:defRPr b="1" sz="1050">
                 <a:solidFill>
                   <a:srgbClr val="2563EB"/>
                 </a:solidFill>
               </a:defRPr>
             </a:pPr>
             <a:r>
-              <a:t>• Đánh giá kết quả tái lập (Replication Result):</a:t>
+              <a:t>• Đánh giá kết quả thực nghiệm tái lập:</a:t>
             </a:r>
           </a:p>
           <a:p>
@@ -11303,14 +11233,14 @@
               <a:spcBef>
                 <a:spcPts val="150"/>
               </a:spcBef>
-              <a:defRPr sz="950">
+              <a:defRPr sz="1000">
                 <a:solidFill>
                   <a:srgbClr val="0F172A"/>
                 </a:solidFill>
               </a:defRPr>
             </a:pPr>
             <a:r>
-              <a:t>Cả 3 mô hình đều phát hiện chính xác 100% mọi hành vi tấn công, hoàn thành trọn vẹn yêu cầu tái lập kết quả bài báo khoa học gốc.</a:t>
+              <a:t>Cả 3 mô hình nền tảng đều phát hiện chính xác 100% các hành vi tấn công sửa đổi tệp, hoàn thành trọn vẹn mục tiêu hiện thực hóa và kiểm thử thực nghiệm trên tập dữ liệu thực tế.</a:t>
             </a:r>
           </a:p>
         </p:txBody>
@@ -11390,7 +11320,7 @@
               </a:defRPr>
             </a:pPr>
             <a:r>
-              <a:t>[ KHUNG CHỜ SƠ ĐỒ DRAW.IO: SƠ ĐỒ CHUYỂN GIAO TRI THỨC TỪ BÀI BÁO OXFORD ĐẾN ĐỒ ÁN DT005 ]</a:t>
+              <a:t>[ KHUNG CHỜ SƠ ĐỒ DRAW.IO: SƠ ĐỒ KIẾN TRÚC HOẠT ĐỘNG CỦA 3 MÔ HÌNH KIỂM TRA TOÀN VẸN NỀN TẢNG ]</a:t>
             </a:r>
           </a:p>
           <a:p>
@@ -11435,7 +11365,7 @@
               </a:defRPr>
             </a:pPr>
             <a:r>
-              <a:t>• Khối 1: Nền tảng triết học mật mã học của Harry Halpin (2025) và khái niệm Kẻ thù hình thức.</a:t>
+              <a:t>• Khối 1: Mô hình băm phẳng SHA-256: Tệp tin dữ liệu -&gt; Băm SHA-256 từng tệp -&gt; Tạo danh mục băm Manifest -&gt; Máy khách tải toàn bộ danh mục để so khớp tuần tự.</a:t>
             </a:r>
           </a:p>
           <a:p>
@@ -11450,7 +11380,7 @@
               </a:defRPr>
             </a:pPr>
             <a:r>
-              <a:t>• Khối 2: Khoảng trống khoa học bài báo: không có mã nguồn, không có dữ liệu, không có đo đạc định lượng.</a:t>
+              <a:t>• Khối 2: Mô hình băm có khóa HMAC-SHA256: Tệp tin kết hợp Khóa bí mật K -&gt; Băm mã xác thực HMAC -&gt; Chống giả mạo danh mục nhưng đòi hỏi phân phối khóa an toàn.</a:t>
             </a:r>
           </a:p>
           <a:p>
@@ -11465,7 +11395,7 @@
               </a:defRPr>
             </a:pPr>
             <a:r>
-              <a:t>• Khối 3: Đóng góp hiện thực hóa của đồ án DT005: PoC HD-MerkleTree, 7 Games an ninh, 2 tập dữ liệu Kaggle.</a:t>
+              <a:t>• Khối 3: Mô hình Cây Merkle nhị phân truyền thống: Tệp tin -&gt; Băm nút lá -&gt; Ghép băm từng đôi lên nút cha -&gt; Chuỗi băm gốc Merkle Root và Bằng chứng Merkle Proof.</a:t>
             </a:r>
           </a:p>
           <a:p>
@@ -11480,7 +11410,7 @@
               </a:defRPr>
             </a:pPr>
             <a:r>
-              <a:t>• Khối 4: Quy trình kiểm nghiệm toán học độc lập và đối chuẩn thực nghiệm đa tầng.</a:t>
+              <a:t>• Khối 4: Quy trình xác minh độc lập của máy khách: Máy khách nhận tệp tin và băm hoặc bằng chứng tương ứng -&gt; Tính lại giá trị băm tại chỗ -&gt; So khớp trực tiếp để phát hiện sai khác.</a:t>
             </a:r>
           </a:p>
           <a:p>
@@ -11495,7 +11425,7 @@
               </a:defRPr>
             </a:pPr>
             <a:r>
-              <a:t>• Mũi tên luồng: Thể hiện chuỗi kế thừa lý thuyết và phát triển thực nghiệm khép kín.</a:t>
+              <a:t>• Mũi tên luồng: Thể hiện chuỗi xử lý từ tệp tin gốc đến cấu trúc xác thực và quy trình kiểm tra toàn vẹn của máy khách.</a:t>
             </a:r>
           </a:p>
         </p:txBody>

</xml_diff>